<commit_message>
Add scaling costs, revenue channels, dynamic pricing to deck/docs/site
- Presentation: 18 slides (scaling+cost, gift/CSR/marketplace revenue, dynamic pricing x2)
- docs/FINANCIALS.md: sections 3b (100-200k scale costs) and 4b (dynamic monetization)
- docs/tech-stack.md: national scale architecture notes
- site/index.html: new #dynamicka-cena section mirroring FINANCIALS.md 4b
</commit_message>
<xml_diff>
--- a/marketing/fynd-x-club-development.pptx
+++ b/marketing/fynd-x-club-development.pptx
@@ -17,8 +17,12 @@
     <p:sldId id="269" r:id="rId20"/>
     <p:sldId id="262" r:id="rId8"/>
     <p:sldId id="263" r:id="rId9"/>
+    <p:sldId id="273" r:id="rId24"/>
+    <p:sldId id="274" r:id="rId25"/>
+    <p:sldId id="275" r:id="rId26"/>
     <p:sldId id="270" r:id="rId21"/>
     <p:sldId id="271" r:id="rId22"/>
+    <p:sldId id="272" r:id="rId23"/>
     <p:sldId id="264" r:id="rId10"/>
     <p:sldId id="265" r:id="rId11"/>
     <p:sldId id="266" r:id="rId12"/>
@@ -2744,7 +2748,7 @@
                 <a:ea typeface="Arial" pitchFamily="34" charset="-122"/>
                 <a:cs typeface="Arial" pitchFamily="34" charset="-120"/>
               </a:rPr>
-              <a:t>NAVYŠE Č. 3 — SKAUTING</a:t>
+              <a:t>ĎALŠIE PRÍJMOVÉ KANÁLY</a:t>
             </a:r>
             <a:endParaRPr lang="en-US" sz="1050" dirty="0"/>
           </a:p>
@@ -2783,7 +2787,7 @@
                 <a:ea typeface="Arial" pitchFamily="34" charset="-122"/>
                 <a:cs typeface="Arial" pitchFamily="34" charset="-120"/>
               </a:rPr>
-              <a:t>Talent viditeľný ďalej než len na tribúne</a:t>
+              <a:t>Peniaze odinakiaľ, nie od rodiča navyše</a:t>
             </a:r>
             <a:endParaRPr lang="en-US" sz="2500" dirty="0"/>
           </a:p>
@@ -2822,7 +2826,7 @@
                 <a:ea typeface="Arial" pitchFamily="34" charset="-122"/>
                 <a:cs typeface="Arial" pitchFamily="34" charset="-120"/>
               </a:rPr>
-              <a:t>Samostatný platený tier pre skautov a agentov — vždy s výslovným súhlasom hráča (a rodiča).</a:t>
+              <a:t>Tri smery, ktoré rozširujú model bez toho, aby čokoľvek zdraželo existujúcim používateľom.</a:t>
             </a:r>
             <a:endParaRPr lang="en-US" sz="1300" dirty="0"/>
           </a:p>
@@ -2958,7 +2962,7 @@
                 <a:ea typeface="Arial" pitchFamily="34" charset="-122"/>
                 <a:cs typeface="Arial" pitchFamily="34" charset="-120"/>
               </a:rPr>
-              <a:t>Súhlas podľa veku</a:t>
+              <a:t>Darovanie Fynd+ Hráč</a:t>
             </a:r>
             <a:endParaRPr lang="en-US" sz="1450" dirty="0"/>
           </a:p>
@@ -3000,7 +3004,7 @@
                 <a:ea typeface="Arial" pitchFamily="34" charset="-122"/>
                 <a:cs typeface="Arial" pitchFamily="34" charset="-120"/>
               </a:rPr>
-              <a:t>15+ si hráč sám zapne viditeľnosť pre skautov. Pod 15 rokov naviac potvrdí rodič.</a:t>
+              <a:t>Starí rodičia, fanúšikovia či firmy môžu darovať prémiový profil konkrétnemu dieťaťu — nezávisle od rozpočtu rodiny.</a:t>
             </a:r>
             <a:endParaRPr lang="en-US" sz="1050" dirty="0"/>
           </a:p>
@@ -3136,7 +3140,7 @@
                 <a:ea typeface="Arial" pitchFamily="34" charset="-122"/>
                 <a:cs typeface="Arial" pitchFamily="34" charset="-120"/>
               </a:rPr>
-              <a:t>Čo skaut vidí</a:t>
+              <a:t>Firemný CSR kanál</a:t>
             </a:r>
             <a:endParaRPr lang="en-US" sz="1450" dirty="0"/>
           </a:p>
@@ -3178,7 +3182,7 @@
                 <a:ea typeface="Arial" pitchFamily="34" charset="-122"/>
                 <a:cs typeface="Arial" pitchFamily="34" charset="-120"/>
               </a:rPr>
-              <a:t>Dochádzka, XP trend, pozápasové hodnotenia, pozícia a kategória — nikdy kontakt ani osobné údaje.</a:t>
+              <a:t>Zamestnávatelia hromadne kupujú Fynd+ Hráč ako benefit pre deti zamestnancov — väčšie obchody namiesto rodiča po rodičovi.</a:t>
             </a:r>
             <a:endParaRPr lang="en-US" sz="1050" dirty="0"/>
           </a:p>
@@ -3314,7 +3318,7 @@
                 <a:ea typeface="Arial" pitchFamily="34" charset="-122"/>
                 <a:cs typeface="Arial" pitchFamily="34" charset="-120"/>
               </a:rPr>
-              <a:t>Kedykoľvek vypnuteľné</a:t>
+              <a:t>Odmeňovňa ako marketplace</a:t>
             </a:r>
             <a:endParaRPr lang="en-US" sz="1450" dirty="0"/>
           </a:p>
@@ -3356,7 +3360,7 @@
                 <a:ea typeface="Arial" pitchFamily="34" charset="-122"/>
                 <a:cs typeface="Arial" pitchFamily="34" charset="-120"/>
               </a:rPr>
-              <a:t>Opt-in je vratný jedným tlačidlom, žiadne uchovávanie u skauta po vypnutí.</a:t>
+              <a:t>Reálne produkty od športových značiek v katalógu — hráč platí XP zľavou a malým doplatkom, klub nič neskladuje.</a:t>
             </a:r>
             <a:endParaRPr lang="en-US" sz="1050" dirty="0"/>
           </a:p>
@@ -3492,7 +3496,7 @@
                 <a:ea typeface="Arial" pitchFamily="34" charset="-122"/>
                 <a:cs typeface="Arial" pitchFamily="34" charset="-120"/>
               </a:rPr>
-              <a:t>19,99 € / mes.</a:t>
+              <a:t>Provízia namiesto nákladu</a:t>
             </a:r>
             <a:endParaRPr lang="en-US" sz="1450" dirty="0"/>
           </a:p>
@@ -3534,7 +3538,7 @@
                 <a:ea typeface="Arial" pitchFamily="34" charset="-122"/>
                 <a:cs typeface="Arial" pitchFamily="34" charset="-120"/>
               </a:rPr>
-              <a:t>Individuálny účet skauta či agenta — žiadna klubová licencia.</a:t>
+              <a:t>Fynd si necháva 10 – 15 % z každej sprostredkovanej odmeny — z nákladovej položky klubu sa stáva príjem.</a:t>
             </a:r>
             <a:endParaRPr lang="en-US" sz="1050" dirty="0"/>
           </a:p>
@@ -3607,7 +3611,7 @@
                 <a:ea typeface="Arial" pitchFamily="34" charset="-122"/>
                 <a:cs typeface="Arial" pitchFamily="34" charset="-120"/>
               </a:rPr>
-              <a:t>Žiadny nákup bez súhlasu. </a:t>
+              <a:t>Žiadny z týchto kanálov nezvyšuje cenu pre existujúcich. </a:t>
             </a:r>
             <a:r>
               <a:rPr lang="en-US" sz="1100" dirty="0">
@@ -3618,7 +3622,7 @@
                 <a:ea typeface="Arial" pitchFamily="34" charset="-122"/>
                 <a:cs typeface="Arial" pitchFamily="34" charset="-120"/>
               </a:rPr>
-              <a:t>Hráč aj rodič vidia presne, kto a čo si pozrel.</a:t>
+              <a:t>Sú to nové cesty k peniazom, nie nové poplatky.</a:t>
             </a:r>
             <a:endParaRPr lang="en-US" sz="1100" dirty="0"/>
           </a:p>
@@ -3720,7 +3724,7 @@
                 <a:ea typeface="Arial" pitchFamily="34" charset="-122"/>
                 <a:cs typeface="Arial" pitchFamily="34" charset="-120"/>
               </a:rPr>
-              <a:t>10 / 14</a:t>
+              <a:t>10 / 18</a:t>
             </a:r>
             <a:endParaRPr lang="en-US" sz="850" dirty="0"/>
           </a:p>
@@ -3822,7 +3826,7 @@
                 <a:ea typeface="Arial" pitchFamily="34" charset="-122"/>
                 <a:cs typeface="Arial" pitchFamily="34" charset="-120"/>
               </a:rPr>
-              <a:t>TECHNICKÝ DODATOK</a:t>
+              <a:t>DYNAMICKÁ MONETIZÁCIA I</a:t>
             </a:r>
             <a:endParaRPr lang="en-US" sz="1050" dirty="0"/>
           </a:p>
@@ -3861,7 +3865,7 @@
                 <a:ea typeface="Arial" pitchFamily="34" charset="-122"/>
                 <a:cs typeface="Arial" pitchFamily="34" charset="-120"/>
               </a:rPr>
-              <a:t>Ako je to postavené (v skratke)</a:t>
+              <a:t>Platíš menej, čím viac hráš a zdieľaš</a:t>
             </a:r>
             <a:endParaRPr lang="en-US" sz="2500" dirty="0"/>
           </a:p>
@@ -3900,7 +3904,7 @@
                 <a:ea typeface="Arial" pitchFamily="34" charset="-122"/>
                 <a:cs typeface="Arial" pitchFamily="34" charset="-120"/>
               </a:rPr>
-              <a:t>Plný technický popis je verejne v repozitári — tu len prehľad pre kontext.</a:t>
+              <a:t>Tri zľavy, ktoré odmeňujú aktivitu a organický rast — nie fakturačné triky.</a:t>
             </a:r>
             <a:endParaRPr lang="en-US" sz="1300" dirty="0"/>
           </a:p>
@@ -4036,7 +4040,7 @@
                 <a:ea typeface="Arial" pitchFamily="34" charset="-122"/>
                 <a:cs typeface="Arial" pitchFamily="34" charset="-120"/>
               </a:rPr>
-              <a:t>Frontend</a:t>
+              <a:t>Zľava za streak/XP</a:t>
             </a:r>
             <a:endParaRPr lang="en-US" sz="1450" dirty="0"/>
           </a:p>
@@ -4078,7 +4082,7 @@
                 <a:ea typeface="Arial" pitchFamily="34" charset="-122"/>
                 <a:cs typeface="Arial" pitchFamily="34" charset="-120"/>
               </a:rPr>
-              <a:t>Progressive Web App — React, TypeScript, Tailwind. Bez povinného App Store.</a:t>
+              <a:t>Dlhší streak alebo vyššie XP = lacnejší Fynd+ Hráč, napr. -20 % pri 30-dňovom streaku. Len na kozmetiku, nikdy na výhodu.</a:t>
             </a:r>
             <a:endParaRPr lang="en-US" sz="1050" dirty="0"/>
           </a:p>
@@ -4214,7 +4218,7 @@
                 <a:ea typeface="Arial" pitchFamily="34" charset="-122"/>
                 <a:cs typeface="Arial" pitchFamily="34" charset="-120"/>
               </a:rPr>
-              <a:t>Backend</a:t>
+              <a:t>Rodinná zľava</a:t>
             </a:r>
             <a:endParaRPr lang="en-US" sz="1450" dirty="0"/>
           </a:p>
@@ -4256,7 +4260,7 @@
                 <a:ea typeface="Arial" pitchFamily="34" charset="-122"/>
                 <a:cs typeface="Arial" pitchFamily="34" charset="-120"/>
               </a:rPr>
-              <a:t>Node.js + Express, TypeScript. Rýchlejšie MVP: Supabase.</a:t>
+              <a:t>Druhé dieťa pod tým istým rodičovským účtom -25 %, tretie a ďalšie zadarmo.</a:t>
             </a:r>
             <a:endParaRPr lang="en-US" sz="1050" dirty="0"/>
           </a:p>
@@ -4392,7 +4396,7 @@
                 <a:ea typeface="Arial" pitchFamily="34" charset="-122"/>
                 <a:cs typeface="Arial" pitchFamily="34" charset="-120"/>
               </a:rPr>
-              <a:t>Databáza</a:t>
+              <a:t>Odporúčací bonus</a:t>
             </a:r>
             <a:endParaRPr lang="en-US" sz="1450" dirty="0"/>
           </a:p>
@@ -4434,7 +4438,7 @@
                 <a:ea typeface="Arial" pitchFamily="34" charset="-122"/>
                 <a:cs typeface="Arial" pitchFamily="34" charset="-120"/>
               </a:rPr>
-              <a:t>PostgreSQL — hráči, kluby, tréningy, XP udalosti, odznaky, Odmeňovňa, skautský opt-in.</a:t>
+              <a:t>Pozvi rodiča/hráča, ktorý sa stane platiacim → mesiac Fynd+ zadarmo pre teba.</a:t>
             </a:r>
             <a:endParaRPr lang="en-US" sz="1050" dirty="0"/>
           </a:p>
@@ -4570,7 +4574,7 @@
                 <a:ea typeface="Arial" pitchFamily="34" charset="-122"/>
                 <a:cs typeface="Arial" pitchFamily="34" charset="-120"/>
               </a:rPr>
-              <a:t>Kde nájsť viac</a:t>
+              <a:t>Prečo sa rodinná zľava nedá fakovať</a:t>
             </a:r>
             <a:endParaRPr lang="en-US" sz="1450" dirty="0"/>
           </a:p>
@@ -4612,7 +4616,7 @@
                 <a:ea typeface="Arial" pitchFamily="34" charset="-122"/>
                 <a:cs typeface="Arial" pitchFamily="34" charset="-120"/>
               </a:rPr>
-              <a:t>docs/tech-stack.md, docs/premium-profiles.md — github.com/tadawur/fynd</a:t>
+              <a:t>Každý profil overuje registrácia SFZ (Sportnet) — fiktívne dieťa bez reálnej registrácie nejde vytvoriť.</a:t>
             </a:r>
             <a:endParaRPr lang="en-US" sz="1050" dirty="0"/>
           </a:p>
@@ -4685,7 +4689,7 @@
                 <a:ea typeface="Arial" pitchFamily="34" charset="-122"/>
                 <a:cs typeface="Arial" pitchFamily="34" charset="-120"/>
               </a:rPr>
-              <a:t>Žiadny vendor lock-in. </a:t>
+              <a:t>Zľavy sledujú správanie, nie platobnú kartu. </a:t>
             </a:r>
             <a:r>
               <a:rPr lang="en-US" sz="1100" dirty="0">
@@ -4696,7 +4700,7 @@
                 <a:ea typeface="Arial" pitchFamily="34" charset="-122"/>
                 <a:cs typeface="Arial" pitchFamily="34" charset="-120"/>
               </a:rPr>
-              <a:t>Bežné open-source technológie, jednoducho nahraditeľné a auditovateľné.</a:t>
+              <a:t>Čím viac hráč trénuje a zdieľa appku, tým menej platí — ekonomika a gamifikácia ťahajú za jeden povraz.</a:t>
             </a:r>
             <a:endParaRPr lang="en-US" sz="1100" dirty="0"/>
           </a:p>
@@ -4798,7 +4802,7 @@
                 <a:ea typeface="Arial" pitchFamily="34" charset="-122"/>
                 <a:cs typeface="Arial" pitchFamily="34" charset="-120"/>
               </a:rPr>
-              <a:t>11 / 14</a:t>
+              <a:t>11 / 18</a:t>
             </a:r>
             <a:endParaRPr lang="en-US" sz="850" dirty="0"/>
           </a:p>
@@ -4816,6 +4820,4318 @@
 </file>
 
 <file path=ppt/slides/slide12.xml><?xml version="1.0" encoding="utf-8"?>
+<p:sld xmlns:a="http://schemas.openxmlformats.org/drawingml/2006/main" xmlns:r="http://schemas.openxmlformats.org/officeDocument/2006/relationships" xmlns:p="http://schemas.openxmlformats.org/presentationml/2006/main">
+  <p:cSld name="Slide 4">
+    <p:bg>
+      <p:bgPr>
+        <a:solidFill>
+          <a:srgbClr val="06101E"/>
+        </a:solidFill>
+        <a:effectLst/>
+      </p:bgPr>
+    </p:bg>
+    <p:spTree>
+      <p:nvGrpSpPr>
+        <p:cNvPr id="1" name=""/>
+        <p:cNvGrpSpPr/>
+        <p:nvPr/>
+      </p:nvGrpSpPr>
+      <p:grpSpPr>
+        <a:xfrm>
+          <a:off x="0" y="0"/>
+          <a:ext cx="0" cy="0"/>
+          <a:chOff x="0" y="0"/>
+          <a:chExt cx="0" cy="0"/>
+        </a:xfrm>
+      </p:grpSpPr>
+      <p:sp>
+        <p:nvSpPr>
+          <p:cNvPr id="2" name="Shape 0"/>
+          <p:cNvSpPr/>
+          <p:nvPr/>
+        </p:nvSpPr>
+        <p:spPr>
+          <a:xfrm>
+            <a:off x="548640" y="461772"/>
+            <a:ext cx="82296" cy="82296"/>
+          </a:xfrm>
+          <a:prstGeom prst="ellipse">
+            <a:avLst/>
+          </a:prstGeom>
+          <a:solidFill>
+            <a:srgbClr val="00D97E"/>
+          </a:solidFill>
+          <a:ln/>
+        </p:spPr>
+        <p:txBody>
+          <a:bodyPr/>
+          <a:lstStyle/>
+          <a:p>
+            <a:endParaRPr lang="sk-SK"/>
+          </a:p>
+        </p:txBody>
+      </p:sp>
+      <p:sp>
+        <p:nvSpPr>
+          <p:cNvPr id="3" name="Text 1"/>
+          <p:cNvSpPr/>
+          <p:nvPr/>
+        </p:nvSpPr>
+        <p:spPr>
+          <a:xfrm>
+            <a:off x="713232" y="402336"/>
+            <a:ext cx="7863840" cy="237744"/>
+          </a:xfrm>
+          <a:prstGeom prst="rect">
+            <a:avLst/>
+          </a:prstGeom>
+          <a:noFill/>
+          <a:ln/>
+        </p:spPr>
+        <p:txBody>
+          <a:bodyPr wrap="square" lIns="0" tIns="0" rIns="0" bIns="0" rtlCol="0" anchor="ctr"/>
+          <a:lstStyle/>
+          <a:p>
+            <a:pPr marL="0" indent="0">
+              <a:buNone/>
+            </a:pPr>
+            <a:r>
+              <a:rPr lang="en-US" sz="1050" b="1" kern="0" spc="320" dirty="0">
+                <a:solidFill>
+                  <a:srgbClr val="00D97E"/>
+                </a:solidFill>
+                <a:latin typeface="Arial" pitchFamily="34" charset="0"/>
+                <a:ea typeface="Arial" pitchFamily="34" charset="-122"/>
+                <a:cs typeface="Arial" pitchFamily="34" charset="-120"/>
+              </a:rPr>
+              <a:t>DYNAMICKÁ MONETIZÁCIA II</a:t>
+            </a:r>
+            <a:endParaRPr lang="en-US" sz="1050" dirty="0"/>
+          </a:p>
+        </p:txBody>
+      </p:sp>
+      <p:sp>
+        <p:nvSpPr>
+          <p:cNvPr id="4" name="Text 2"/>
+          <p:cNvSpPr/>
+          <p:nvPr/>
+        </p:nvSpPr>
+        <p:spPr>
+          <a:xfrm>
+            <a:off x="548640" y="676656"/>
+            <a:ext cx="8046720" cy="502920"/>
+          </a:xfrm>
+          <a:prstGeom prst="rect">
+            <a:avLst/>
+          </a:prstGeom>
+          <a:noFill/>
+          <a:ln/>
+        </p:spPr>
+        <p:txBody>
+          <a:bodyPr wrap="square" lIns="0" tIns="0" rIns="0" bIns="0" rtlCol="0" anchor="ctr"/>
+          <a:lstStyle/>
+          <a:p>
+            <a:pPr marL="0" indent="0">
+              <a:buNone/>
+            </a:pPr>
+            <a:r>
+              <a:rPr lang="en-US" sz="2500" b="1" dirty="0">
+                <a:solidFill>
+                  <a:srgbClr val="F1F6FB"/>
+                </a:solidFill>
+                <a:latin typeface="Arial" pitchFamily="34" charset="0"/>
+                <a:ea typeface="Arial" pitchFamily="34" charset="-122"/>
+                <a:cs typeface="Arial" pitchFamily="34" charset="-120"/>
+              </a:rPr>
+              <a:t>Cena dýcha s aktivitou, nie je fixná celý rok</a:t>
+            </a:r>
+            <a:endParaRPr lang="en-US" sz="2500" dirty="0"/>
+          </a:p>
+        </p:txBody>
+      </p:sp>
+      <p:sp>
+        <p:nvSpPr>
+          <p:cNvPr id="5" name="Text 3"/>
+          <p:cNvSpPr/>
+          <p:nvPr/>
+        </p:nvSpPr>
+        <p:spPr>
+          <a:xfrm>
+            <a:off x="548640" y="1188720"/>
+            <a:ext cx="8046720" cy="320040"/>
+          </a:xfrm>
+          <a:prstGeom prst="rect">
+            <a:avLst/>
+          </a:prstGeom>
+          <a:noFill/>
+          <a:ln/>
+        </p:spPr>
+        <p:txBody>
+          <a:bodyPr wrap="square" lIns="0" tIns="0" rIns="0" bIns="0" rtlCol="0" anchor="ctr"/>
+          <a:lstStyle/>
+          <a:p>
+            <a:pPr marL="0" indent="0">
+              <a:buNone/>
+            </a:pPr>
+            <a:r>
+              <a:rPr lang="en-US" sz="1300" dirty="0">
+                <a:solidFill>
+                  <a:srgbClr val="8CA6C0"/>
+                </a:solidFill>
+                <a:latin typeface="Arial" pitchFamily="34" charset="0"/>
+                <a:ea typeface="Arial" pitchFamily="34" charset="-122"/>
+                <a:cs typeface="Arial" pitchFamily="34" charset="-120"/>
+              </a:rPr>
+              <a:t>Nižšie vstupné riziko a menej strateného predplatného cez mŕtve obdobie.</a:t>
+            </a:r>
+            <a:endParaRPr lang="en-US" sz="1300" dirty="0"/>
+          </a:p>
+        </p:txBody>
+      </p:sp>
+      <p:sp>
+        <p:nvSpPr>
+          <p:cNvPr id="6" name="Shape 4"/>
+          <p:cNvSpPr/>
+          <p:nvPr/>
+        </p:nvSpPr>
+        <p:spPr>
+          <a:xfrm>
+            <a:off x="548640" y="1591056"/>
+            <a:ext cx="3886200" cy="1280160"/>
+          </a:xfrm>
+          <a:prstGeom prst="roundRect">
+            <a:avLst>
+              <a:gd name="adj" fmla="val 6429"/>
+            </a:avLst>
+          </a:prstGeom>
+          <a:solidFill>
+            <a:srgbClr val="1A2C42"/>
+          </a:solidFill>
+          <a:ln w="9525">
+            <a:solidFill>
+              <a:srgbClr val="24364D"/>
+            </a:solidFill>
+            <a:prstDash val="solid"/>
+          </a:ln>
+          <a:effectLst>
+            <a:outerShdw blurRad="114300" dist="38100" dir="3600000" algn="bl" rotWithShape="0">
+              <a:srgbClr val="000000">
+                <a:alpha val="35000"/>
+              </a:srgbClr>
+            </a:outerShdw>
+          </a:effectLst>
+        </p:spPr>
+        <p:txBody>
+          <a:bodyPr/>
+          <a:lstStyle/>
+          <a:p>
+            <a:endParaRPr lang="sk-SK"/>
+          </a:p>
+        </p:txBody>
+      </p:sp>
+      <p:sp>
+        <p:nvSpPr>
+          <p:cNvPr id="7" name="Shape 5"/>
+          <p:cNvSpPr/>
+          <p:nvPr/>
+        </p:nvSpPr>
+        <p:spPr>
+          <a:xfrm>
+            <a:off x="749808" y="1737360"/>
+            <a:ext cx="475488" cy="475488"/>
+          </a:xfrm>
+          <a:prstGeom prst="ellipse">
+            <a:avLst/>
+          </a:prstGeom>
+          <a:solidFill>
+            <a:srgbClr val="1A2C42"/>
+          </a:solidFill>
+          <a:ln w="9525">
+            <a:solidFill>
+              <a:srgbClr val="24364D"/>
+            </a:solidFill>
+            <a:prstDash val="solid"/>
+          </a:ln>
+        </p:spPr>
+        <p:txBody>
+          <a:bodyPr/>
+          <a:lstStyle/>
+          <a:p>
+            <a:endParaRPr lang="sk-SK"/>
+          </a:p>
+        </p:txBody>
+      </p:sp>
+      <p:pic>
+        <p:nvPicPr>
+          <p:cNvPr id="8" name="Image 0" descr="preencoded.png"/>
+          <p:cNvPicPr>
+            <a:picLocks noChangeAspect="1"/>
+          </p:cNvPicPr>
+          <p:nvPr/>
+        </p:nvPicPr>
+        <p:blipFill>
+          <a:blip r:embed="rId3"/>
+          <a:stretch>
+            <a:fillRect/>
+          </a:stretch>
+        </p:blipFill>
+        <p:spPr>
+          <a:xfrm>
+            <a:off x="878190" y="1865742"/>
+            <a:ext cx="218724" cy="218724"/>
+          </a:xfrm>
+          <a:prstGeom prst="rect">
+            <a:avLst/>
+          </a:prstGeom>
+        </p:spPr>
+      </p:pic>
+      <p:sp>
+        <p:nvSpPr>
+          <p:cNvPr id="9" name="Text 6"/>
+          <p:cNvSpPr/>
+          <p:nvPr/>
+        </p:nvSpPr>
+        <p:spPr>
+          <a:xfrm>
+            <a:off x="1389888" y="1709928"/>
+            <a:ext cx="2880360" cy="310896"/>
+          </a:xfrm>
+          <a:prstGeom prst="rect">
+            <a:avLst/>
+          </a:prstGeom>
+          <a:noFill/>
+          <a:ln/>
+        </p:spPr>
+        <p:txBody>
+          <a:bodyPr wrap="square" lIns="0" tIns="0" rIns="0" bIns="0" rtlCol="0" anchor="ctr"/>
+          <a:lstStyle/>
+          <a:p>
+            <a:pPr marL="0" indent="0">
+              <a:buNone/>
+            </a:pPr>
+            <a:r>
+              <a:rPr lang="en-US" sz="1450" b="1" dirty="0">
+                <a:solidFill>
+                  <a:srgbClr val="F1F6FB"/>
+                </a:solidFill>
+                <a:latin typeface="Arial" pitchFamily="34" charset="0"/>
+                <a:ea typeface="Arial" pitchFamily="34" charset="-122"/>
+                <a:cs typeface="Arial" pitchFamily="34" charset="-120"/>
+              </a:rPr>
+              <a:t>Klub tier lacnejší cez leto</a:t>
+            </a:r>
+            <a:endParaRPr lang="en-US" sz="1450" dirty="0"/>
+          </a:p>
+        </p:txBody>
+      </p:sp>
+      <p:sp>
+        <p:nvSpPr>
+          <p:cNvPr id="10" name="Text 7"/>
+          <p:cNvSpPr/>
+          <p:nvPr/>
+        </p:nvSpPr>
+        <p:spPr>
+          <a:xfrm>
+            <a:off x="1389888" y="2048256"/>
+            <a:ext cx="2834640" cy="731520"/>
+          </a:xfrm>
+          <a:prstGeom prst="rect">
+            <a:avLst/>
+          </a:prstGeom>
+          <a:noFill/>
+          <a:ln/>
+        </p:spPr>
+        <p:txBody>
+          <a:bodyPr wrap="square" lIns="0" tIns="0" rIns="0" bIns="0" rtlCol="0" anchor="ctr"/>
+          <a:lstStyle/>
+          <a:p>
+            <a:pPr marL="0" indent="0">
+              <a:lnSpc>
+                <a:spcPct val="108000"/>
+              </a:lnSpc>
+              <a:buNone/>
+            </a:pPr>
+            <a:r>
+              <a:rPr lang="en-US" sz="1050" dirty="0">
+                <a:solidFill>
+                  <a:srgbClr val="8CA6C0"/>
+                </a:solidFill>
+                <a:latin typeface="Arial" pitchFamily="34" charset="0"/>
+                <a:ea typeface="Arial" pitchFamily="34" charset="-122"/>
+                <a:cs typeface="Arial" pitchFamily="34" charset="-120"/>
+              </a:rPr>
+              <a:t>-30 až 40 % počas letnej prestávky namiesto úplného zrušenia predplatného na prázdniny.</a:t>
+            </a:r>
+            <a:endParaRPr lang="en-US" sz="1050" dirty="0"/>
+          </a:p>
+        </p:txBody>
+      </p:sp>
+      <p:sp>
+        <p:nvSpPr>
+          <p:cNvPr id="11" name="Shape 8"/>
+          <p:cNvSpPr/>
+          <p:nvPr/>
+        </p:nvSpPr>
+        <p:spPr>
+          <a:xfrm>
+            <a:off x="4709160" y="1591056"/>
+            <a:ext cx="3886200" cy="1280160"/>
+          </a:xfrm>
+          <a:prstGeom prst="roundRect">
+            <a:avLst>
+              <a:gd name="adj" fmla="val 6429"/>
+            </a:avLst>
+          </a:prstGeom>
+          <a:solidFill>
+            <a:srgbClr val="1A2C42"/>
+          </a:solidFill>
+          <a:ln w="9525">
+            <a:solidFill>
+              <a:srgbClr val="24364D"/>
+            </a:solidFill>
+            <a:prstDash val="solid"/>
+          </a:ln>
+          <a:effectLst>
+            <a:outerShdw blurRad="114300" dist="38100" dir="3600000" algn="bl" rotWithShape="0">
+              <a:srgbClr val="000000">
+                <a:alpha val="35000"/>
+              </a:srgbClr>
+            </a:outerShdw>
+          </a:effectLst>
+        </p:spPr>
+        <p:txBody>
+          <a:bodyPr/>
+          <a:lstStyle/>
+          <a:p>
+            <a:endParaRPr lang="sk-SK"/>
+          </a:p>
+        </p:txBody>
+      </p:sp>
+      <p:sp>
+        <p:nvSpPr>
+          <p:cNvPr id="12" name="Shape 9"/>
+          <p:cNvSpPr/>
+          <p:nvPr/>
+        </p:nvSpPr>
+        <p:spPr>
+          <a:xfrm>
+            <a:off x="4910328" y="1737360"/>
+            <a:ext cx="475488" cy="475488"/>
+          </a:xfrm>
+          <a:prstGeom prst="ellipse">
+            <a:avLst/>
+          </a:prstGeom>
+          <a:solidFill>
+            <a:srgbClr val="1A2C42"/>
+          </a:solidFill>
+          <a:ln w="9525">
+            <a:solidFill>
+              <a:srgbClr val="24364D"/>
+            </a:solidFill>
+            <a:prstDash val="solid"/>
+          </a:ln>
+        </p:spPr>
+        <p:txBody>
+          <a:bodyPr/>
+          <a:lstStyle/>
+          <a:p>
+            <a:endParaRPr lang="sk-SK"/>
+          </a:p>
+        </p:txBody>
+      </p:sp>
+      <p:pic>
+        <p:nvPicPr>
+          <p:cNvPr id="13" name="Image 1" descr="preencoded.png"/>
+          <p:cNvPicPr>
+            <a:picLocks noChangeAspect="1"/>
+          </p:cNvPicPr>
+          <p:nvPr/>
+        </p:nvPicPr>
+        <p:blipFill>
+          <a:blip r:embed="rId4"/>
+          <a:stretch>
+            <a:fillRect/>
+          </a:stretch>
+        </p:blipFill>
+        <p:spPr>
+          <a:xfrm>
+            <a:off x="5038710" y="1865742"/>
+            <a:ext cx="218724" cy="218724"/>
+          </a:xfrm>
+          <a:prstGeom prst="rect">
+            <a:avLst/>
+          </a:prstGeom>
+        </p:spPr>
+      </p:pic>
+      <p:sp>
+        <p:nvSpPr>
+          <p:cNvPr id="14" name="Text 10"/>
+          <p:cNvSpPr/>
+          <p:nvPr/>
+        </p:nvSpPr>
+        <p:spPr>
+          <a:xfrm>
+            <a:off x="5550408" y="1709928"/>
+            <a:ext cx="2880360" cy="310896"/>
+          </a:xfrm>
+          <a:prstGeom prst="rect">
+            <a:avLst/>
+          </a:prstGeom>
+          <a:noFill/>
+          <a:ln/>
+        </p:spPr>
+        <p:txBody>
+          <a:bodyPr wrap="square" lIns="0" tIns="0" rIns="0" bIns="0" rtlCol="0" anchor="ctr"/>
+          <a:lstStyle/>
+          <a:p>
+            <a:pPr marL="0" indent="0">
+              <a:buNone/>
+            </a:pPr>
+            <a:r>
+              <a:rPr lang="en-US" sz="1450" b="1" dirty="0">
+                <a:solidFill>
+                  <a:srgbClr val="F1F6FB"/>
+                </a:solidFill>
+                <a:latin typeface="Arial" pitchFamily="34" charset="0"/>
+                <a:ea typeface="Arial" pitchFamily="34" charset="-122"/>
+                <a:cs typeface="Arial" pitchFamily="34" charset="-120"/>
+              </a:rPr>
+              <a:t>Udrží kontinuitu, nie len cenu</a:t>
+            </a:r>
+            <a:endParaRPr lang="en-US" sz="1450" dirty="0"/>
+          </a:p>
+        </p:txBody>
+      </p:sp>
+      <p:sp>
+        <p:nvSpPr>
+          <p:cNvPr id="15" name="Text 11"/>
+          <p:cNvSpPr/>
+          <p:nvPr/>
+        </p:nvSpPr>
+        <p:spPr>
+          <a:xfrm>
+            <a:off x="5550408" y="2048256"/>
+            <a:ext cx="2834640" cy="731520"/>
+          </a:xfrm>
+          <a:prstGeom prst="rect">
+            <a:avLst/>
+          </a:prstGeom>
+          <a:noFill/>
+          <a:ln/>
+        </p:spPr>
+        <p:txBody>
+          <a:bodyPr wrap="square" lIns="0" tIns="0" rIns="0" bIns="0" rtlCol="0" anchor="ctr"/>
+          <a:lstStyle/>
+          <a:p>
+            <a:pPr marL="0" indent="0">
+              <a:lnSpc>
+                <a:spcPct val="108000"/>
+              </a:lnSpc>
+              <a:buNone/>
+            </a:pPr>
+            <a:r>
+              <a:rPr lang="en-US" sz="1050" dirty="0">
+                <a:solidFill>
+                  <a:srgbClr val="8CA6C0"/>
+                </a:solidFill>
+                <a:latin typeface="Arial" pitchFamily="34" charset="0"/>
+                <a:ea typeface="Arial" pitchFamily="34" charset="-122"/>
+                <a:cs typeface="Arial" pitchFamily="34" charset="-120"/>
+              </a:rPr>
+              <a:t>Klub sa neodhlási a nezabudne sa vrátiť — jeseň začína bez nového onboardingu.</a:t>
+            </a:r>
+            <a:endParaRPr lang="en-US" sz="1050" dirty="0"/>
+          </a:p>
+        </p:txBody>
+      </p:sp>
+      <p:sp>
+        <p:nvSpPr>
+          <p:cNvPr id="16" name="Shape 12"/>
+          <p:cNvSpPr/>
+          <p:nvPr/>
+        </p:nvSpPr>
+        <p:spPr>
+          <a:xfrm>
+            <a:off x="548640" y="2999232"/>
+            <a:ext cx="3886200" cy="1280160"/>
+          </a:xfrm>
+          <a:prstGeom prst="roundRect">
+            <a:avLst>
+              <a:gd name="adj" fmla="val 6429"/>
+            </a:avLst>
+          </a:prstGeom>
+          <a:solidFill>
+            <a:srgbClr val="1A2C42"/>
+          </a:solidFill>
+          <a:ln w="9525">
+            <a:solidFill>
+              <a:srgbClr val="24364D"/>
+            </a:solidFill>
+            <a:prstDash val="solid"/>
+          </a:ln>
+          <a:effectLst>
+            <a:outerShdw blurRad="114300" dist="38100" dir="3600000" algn="bl" rotWithShape="0">
+              <a:srgbClr val="000000">
+                <a:alpha val="35000"/>
+              </a:srgbClr>
+            </a:outerShdw>
+          </a:effectLst>
+        </p:spPr>
+        <p:txBody>
+          <a:bodyPr/>
+          <a:lstStyle/>
+          <a:p>
+            <a:endParaRPr lang="sk-SK"/>
+          </a:p>
+        </p:txBody>
+      </p:sp>
+      <p:sp>
+        <p:nvSpPr>
+          <p:cNvPr id="17" name="Shape 13"/>
+          <p:cNvSpPr/>
+          <p:nvPr/>
+        </p:nvSpPr>
+        <p:spPr>
+          <a:xfrm>
+            <a:off x="749808" y="3145536"/>
+            <a:ext cx="475488" cy="475488"/>
+          </a:xfrm>
+          <a:prstGeom prst="ellipse">
+            <a:avLst/>
+          </a:prstGeom>
+          <a:solidFill>
+            <a:srgbClr val="1A2C42"/>
+          </a:solidFill>
+          <a:ln w="9525">
+            <a:solidFill>
+              <a:srgbClr val="24364D"/>
+            </a:solidFill>
+            <a:prstDash val="solid"/>
+          </a:ln>
+        </p:spPr>
+        <p:txBody>
+          <a:bodyPr/>
+          <a:lstStyle/>
+          <a:p>
+            <a:endParaRPr lang="sk-SK"/>
+          </a:p>
+        </p:txBody>
+      </p:sp>
+      <p:pic>
+        <p:nvPicPr>
+          <p:cNvPr id="18" name="Image 2" descr="preencoded.png"/>
+          <p:cNvPicPr>
+            <a:picLocks noChangeAspect="1"/>
+          </p:cNvPicPr>
+          <p:nvPr/>
+        </p:nvPicPr>
+        <p:blipFill>
+          <a:blip r:embed="rId5"/>
+          <a:stretch>
+            <a:fillRect/>
+          </a:stretch>
+        </p:blipFill>
+        <p:spPr>
+          <a:xfrm>
+            <a:off x="878190" y="3273918"/>
+            <a:ext cx="218724" cy="218724"/>
+          </a:xfrm>
+          <a:prstGeom prst="rect">
+            <a:avLst/>
+          </a:prstGeom>
+        </p:spPr>
+      </p:pic>
+      <p:sp>
+        <p:nvSpPr>
+          <p:cNvPr id="19" name="Text 14"/>
+          <p:cNvSpPr/>
+          <p:nvPr/>
+        </p:nvSpPr>
+        <p:spPr>
+          <a:xfrm>
+            <a:off x="1389888" y="3118104"/>
+            <a:ext cx="2880360" cy="310896"/>
+          </a:xfrm>
+          <a:prstGeom prst="rect">
+            <a:avLst/>
+          </a:prstGeom>
+          <a:noFill/>
+          <a:ln/>
+        </p:spPr>
+        <p:txBody>
+          <a:bodyPr wrap="square" lIns="0" tIns="0" rIns="0" bIns="0" rtlCol="0" anchor="ctr"/>
+          <a:lstStyle/>
+          <a:p>
+            <a:pPr marL="0" indent="0">
+              <a:buNone/>
+            </a:pPr>
+            <a:r>
+              <a:rPr lang="en-US" sz="1450" b="1" dirty="0">
+                <a:solidFill>
+                  <a:srgbClr val="F1F6FB"/>
+                </a:solidFill>
+                <a:latin typeface="Arial" pitchFamily="34" charset="0"/>
+                <a:ea typeface="Arial" pitchFamily="34" charset="-122"/>
+                <a:cs typeface="Arial" pitchFamily="34" charset="-120"/>
+              </a:rPr>
+              <a:t>Sponzoring podľa reálneho dosahu</a:t>
+            </a:r>
+            <a:endParaRPr lang="en-US" sz="1450" dirty="0"/>
+          </a:p>
+        </p:txBody>
+      </p:sp>
+      <p:sp>
+        <p:nvSpPr>
+          <p:cNvPr id="20" name="Text 15"/>
+          <p:cNvSpPr/>
+          <p:nvPr/>
+        </p:nvSpPr>
+        <p:spPr>
+          <a:xfrm>
+            <a:off x="1389888" y="3456432"/>
+            <a:ext cx="2834640" cy="731520"/>
+          </a:xfrm>
+          <a:prstGeom prst="rect">
+            <a:avLst/>
+          </a:prstGeom>
+          <a:noFill/>
+          <a:ln/>
+        </p:spPr>
+        <p:txBody>
+          <a:bodyPr wrap="square" lIns="0" tIns="0" rIns="0" bIns="0" rtlCol="0" anchor="ctr"/>
+          <a:lstStyle/>
+          <a:p>
+            <a:pPr marL="0" indent="0">
+              <a:lnSpc>
+                <a:spcPct val="108000"/>
+              </a:lnSpc>
+              <a:buNone/>
+            </a:pPr>
+            <a:r>
+              <a:rPr lang="en-US" sz="1050" dirty="0">
+                <a:solidFill>
+                  <a:srgbClr val="8CA6C0"/>
+                </a:solidFill>
+                <a:latin typeface="Arial" pitchFamily="34" charset="0"/>
+                <a:ea typeface="Arial" pitchFamily="34" charset="-122"/>
+                <a:cs typeface="Arial" pitchFamily="34" charset="-120"/>
+              </a:rPr>
+              <a:t>Cena sa mení podľa aktivity klubu v danom mesiaci — viac v sezóne, menej cez prázdniny.</a:t>
+            </a:r>
+            <a:endParaRPr lang="en-US" sz="1050" dirty="0"/>
+          </a:p>
+        </p:txBody>
+      </p:sp>
+      <p:sp>
+        <p:nvSpPr>
+          <p:cNvPr id="21" name="Shape 16"/>
+          <p:cNvSpPr/>
+          <p:nvPr/>
+        </p:nvSpPr>
+        <p:spPr>
+          <a:xfrm>
+            <a:off x="4709160" y="2999232"/>
+            <a:ext cx="3886200" cy="1280160"/>
+          </a:xfrm>
+          <a:prstGeom prst="roundRect">
+            <a:avLst>
+              <a:gd name="adj" fmla="val 6429"/>
+            </a:avLst>
+          </a:prstGeom>
+          <a:solidFill>
+            <a:srgbClr val="1A2C42"/>
+          </a:solidFill>
+          <a:ln w="9525">
+            <a:solidFill>
+              <a:srgbClr val="24364D"/>
+            </a:solidFill>
+            <a:prstDash val="solid"/>
+          </a:ln>
+          <a:effectLst>
+            <a:outerShdw blurRad="114300" dist="38100" dir="3600000" algn="bl" rotWithShape="0">
+              <a:srgbClr val="000000">
+                <a:alpha val="35000"/>
+              </a:srgbClr>
+            </a:outerShdw>
+          </a:effectLst>
+        </p:spPr>
+        <p:txBody>
+          <a:bodyPr/>
+          <a:lstStyle/>
+          <a:p>
+            <a:endParaRPr lang="sk-SK"/>
+          </a:p>
+        </p:txBody>
+      </p:sp>
+      <p:sp>
+        <p:nvSpPr>
+          <p:cNvPr id="22" name="Shape 17"/>
+          <p:cNvSpPr/>
+          <p:nvPr/>
+        </p:nvSpPr>
+        <p:spPr>
+          <a:xfrm>
+            <a:off x="4910328" y="3145536"/>
+            <a:ext cx="475488" cy="475488"/>
+          </a:xfrm>
+          <a:prstGeom prst="ellipse">
+            <a:avLst/>
+          </a:prstGeom>
+          <a:solidFill>
+            <a:srgbClr val="1A2C42"/>
+          </a:solidFill>
+          <a:ln w="9525">
+            <a:solidFill>
+              <a:srgbClr val="24364D"/>
+            </a:solidFill>
+            <a:prstDash val="solid"/>
+          </a:ln>
+        </p:spPr>
+        <p:txBody>
+          <a:bodyPr/>
+          <a:lstStyle/>
+          <a:p>
+            <a:endParaRPr lang="sk-SK"/>
+          </a:p>
+        </p:txBody>
+      </p:sp>
+      <p:pic>
+        <p:nvPicPr>
+          <p:cNvPr id="23" name="Image 3" descr="preencoded.png"/>
+          <p:cNvPicPr>
+            <a:picLocks noChangeAspect="1"/>
+          </p:cNvPicPr>
+          <p:nvPr/>
+        </p:nvPicPr>
+        <p:blipFill>
+          <a:blip r:embed="rId6"/>
+          <a:stretch>
+            <a:fillRect/>
+          </a:stretch>
+        </p:blipFill>
+        <p:spPr>
+          <a:xfrm>
+            <a:off x="5038710" y="3273918"/>
+            <a:ext cx="218724" cy="218724"/>
+          </a:xfrm>
+          <a:prstGeom prst="rect">
+            <a:avLst/>
+          </a:prstGeom>
+        </p:spPr>
+      </p:pic>
+      <p:sp>
+        <p:nvSpPr>
+          <p:cNvPr id="24" name="Text 18"/>
+          <p:cNvSpPr/>
+          <p:nvPr/>
+        </p:nvSpPr>
+        <p:spPr>
+          <a:xfrm>
+            <a:off x="5550408" y="3118104"/>
+            <a:ext cx="2880360" cy="310896"/>
+          </a:xfrm>
+          <a:prstGeom prst="rect">
+            <a:avLst/>
+          </a:prstGeom>
+          <a:noFill/>
+          <a:ln/>
+        </p:spPr>
+        <p:txBody>
+          <a:bodyPr wrap="square" lIns="0" tIns="0" rIns="0" bIns="0" rtlCol="0" anchor="ctr"/>
+          <a:lstStyle/>
+          <a:p>
+            <a:pPr marL="0" indent="0">
+              <a:buNone/>
+            </a:pPr>
+            <a:r>
+              <a:rPr lang="en-US" sz="1450" b="1" dirty="0">
+                <a:solidFill>
+                  <a:srgbClr val="F1F6FB"/>
+                </a:solidFill>
+                <a:latin typeface="Arial" pitchFamily="34" charset="0"/>
+                <a:ea typeface="Arial" pitchFamily="34" charset="-122"/>
+                <a:cs typeface="Arial" pitchFamily="34" charset="-120"/>
+              </a:rPr>
+              <a:t>Nižšie vstupné riziko pre sponzora</a:t>
+            </a:r>
+            <a:endParaRPr lang="en-US" sz="1450" dirty="0"/>
+          </a:p>
+        </p:txBody>
+      </p:sp>
+      <p:sp>
+        <p:nvSpPr>
+          <p:cNvPr id="25" name="Text 19"/>
+          <p:cNvSpPr/>
+          <p:nvPr/>
+        </p:nvSpPr>
+        <p:spPr>
+          <a:xfrm>
+            <a:off x="5550408" y="3456432"/>
+            <a:ext cx="2834640" cy="731520"/>
+          </a:xfrm>
+          <a:prstGeom prst="rect">
+            <a:avLst/>
+          </a:prstGeom>
+          <a:noFill/>
+          <a:ln/>
+        </p:spPr>
+        <p:txBody>
+          <a:bodyPr wrap="square" lIns="0" tIns="0" rIns="0" bIns="0" rtlCol="0" anchor="ctr"/>
+          <a:lstStyle/>
+          <a:p>
+            <a:pPr marL="0" indent="0">
+              <a:lnSpc>
+                <a:spcPct val="108000"/>
+              </a:lnSpc>
+              <a:buNone/>
+            </a:pPr>
+            <a:r>
+              <a:rPr lang="en-US" sz="1050" dirty="0">
+                <a:solidFill>
+                  <a:srgbClr val="8CA6C0"/>
+                </a:solidFill>
+                <a:latin typeface="Arial" pitchFamily="34" charset="0"/>
+                <a:ea typeface="Arial" pitchFamily="34" charset="-122"/>
+                <a:cs typeface="Arial" pitchFamily="34" charset="-120"/>
+              </a:rPr>
+              <a:t>Menší záväzok na skúšku → viac lokálnych firiem ochotných to vôbec vyskúšať.</a:t>
+            </a:r>
+            <a:endParaRPr lang="en-US" sz="1050" dirty="0"/>
+          </a:p>
+        </p:txBody>
+      </p:sp>
+      <p:sp>
+        <p:nvSpPr>
+          <p:cNvPr id="26" name="Shape 20"/>
+          <p:cNvSpPr/>
+          <p:nvPr/>
+        </p:nvSpPr>
+        <p:spPr>
+          <a:xfrm>
+            <a:off x="548640" y="4370832"/>
+            <a:ext cx="8046720" cy="347472"/>
+          </a:xfrm>
+          <a:prstGeom prst="roundRect">
+            <a:avLst>
+              <a:gd name="adj" fmla="val 50000"/>
+            </a:avLst>
+          </a:prstGeom>
+          <a:solidFill>
+            <a:srgbClr val="0D1B2E"/>
+          </a:solidFill>
+          <a:ln w="12700">
+            <a:solidFill>
+              <a:srgbClr val="00D97E"/>
+            </a:solidFill>
+            <a:prstDash val="solid"/>
+          </a:ln>
+        </p:spPr>
+        <p:txBody>
+          <a:bodyPr/>
+          <a:lstStyle/>
+          <a:p>
+            <a:endParaRPr lang="sk-SK"/>
+          </a:p>
+        </p:txBody>
+      </p:sp>
+      <p:sp>
+        <p:nvSpPr>
+          <p:cNvPr id="27" name="Text 21"/>
+          <p:cNvSpPr/>
+          <p:nvPr/>
+        </p:nvSpPr>
+        <p:spPr>
+          <a:xfrm>
+            <a:off x="822960" y="4370832"/>
+            <a:ext cx="7498080" cy="347472"/>
+          </a:xfrm>
+          <a:prstGeom prst="rect">
+            <a:avLst/>
+          </a:prstGeom>
+          <a:noFill/>
+          <a:ln/>
+        </p:spPr>
+        <p:txBody>
+          <a:bodyPr wrap="square" lIns="0" tIns="0" rIns="0" bIns="0" rtlCol="0" anchor="ctr"/>
+          <a:lstStyle/>
+          <a:p>
+            <a:pPr marL="0" indent="0">
+              <a:buNone/>
+            </a:pPr>
+            <a:r>
+              <a:rPr lang="en-US" sz="1100" b="1" dirty="0">
+                <a:solidFill>
+                  <a:srgbClr val="00D97E"/>
+                </a:solidFill>
+                <a:latin typeface="Arial" pitchFamily="34" charset="0"/>
+                <a:ea typeface="Arial" pitchFamily="34" charset="-122"/>
+                <a:cs typeface="Arial" pitchFamily="34" charset="-120"/>
+              </a:rPr>
+              <a:t>Fixná cena ignoruje sezónnosť športu. </a:t>
+            </a:r>
+            <a:r>
+              <a:rPr lang="en-US" sz="1100" dirty="0">
+                <a:solidFill>
+                  <a:srgbClr val="8CA6C0"/>
+                </a:solidFill>
+                <a:latin typeface="Arial" pitchFamily="34" charset="0"/>
+                <a:ea typeface="Arial" pitchFamily="34" charset="-122"/>
+                <a:cs typeface="Arial" pitchFamily="34" charset="-120"/>
+              </a:rPr>
+              <a:t>Dynamická cena kopíruje reálny cyklus klubu namiesto plochej sadzby po celý rok.</a:t>
+            </a:r>
+            <a:endParaRPr lang="en-US" sz="1100" dirty="0"/>
+          </a:p>
+        </p:txBody>
+      </p:sp>
+      <p:pic>
+        <p:nvPicPr>
+          <p:cNvPr id="28" name="Image 4" descr="preencoded.png"/>
+          <p:cNvPicPr>
+            <a:picLocks noChangeAspect="1"/>
+          </p:cNvPicPr>
+          <p:nvPr/>
+        </p:nvPicPr>
+        <p:blipFill>
+          <a:blip r:embed="rId7"/>
+          <a:stretch>
+            <a:fillRect/>
+          </a:stretch>
+        </p:blipFill>
+        <p:spPr>
+          <a:xfrm>
+            <a:off x="548640" y="4828032"/>
+            <a:ext cx="155448" cy="155448"/>
+          </a:xfrm>
+          <a:prstGeom prst="rect">
+            <a:avLst/>
+          </a:prstGeom>
+        </p:spPr>
+      </p:pic>
+      <p:sp>
+        <p:nvSpPr>
+          <p:cNvPr id="29" name="Text 22"/>
+          <p:cNvSpPr/>
+          <p:nvPr/>
+        </p:nvSpPr>
+        <p:spPr>
+          <a:xfrm>
+            <a:off x="777240" y="4809744"/>
+            <a:ext cx="3200400" cy="201168"/>
+          </a:xfrm>
+          <a:prstGeom prst="rect">
+            <a:avLst/>
+          </a:prstGeom>
+          <a:noFill/>
+          <a:ln/>
+        </p:spPr>
+        <p:txBody>
+          <a:bodyPr wrap="square" lIns="0" tIns="0" rIns="0" bIns="0" rtlCol="0" anchor="ctr"/>
+          <a:lstStyle/>
+          <a:p>
+            <a:pPr marL="0" indent="0">
+              <a:buNone/>
+            </a:pPr>
+            <a:r>
+              <a:rPr lang="en-US" sz="850" dirty="0">
+                <a:solidFill>
+                  <a:srgbClr val="8CA6C0"/>
+                </a:solidFill>
+                <a:latin typeface="Arial" pitchFamily="34" charset="0"/>
+                <a:ea typeface="Arial" pitchFamily="34" charset="-122"/>
+                <a:cs typeface="Arial" pitchFamily="34" charset="-120"/>
+              </a:rPr>
+              <a:t>fynd.fans — Beyond the Score</a:t>
+            </a:r>
+            <a:endParaRPr lang="en-US" sz="850" dirty="0"/>
+          </a:p>
+        </p:txBody>
+      </p:sp>
+      <p:sp>
+        <p:nvSpPr>
+          <p:cNvPr id="30" name="Text 23"/>
+          <p:cNvSpPr/>
+          <p:nvPr/>
+        </p:nvSpPr>
+        <p:spPr>
+          <a:xfrm>
+            <a:off x="7680960" y="4809744"/>
+            <a:ext cx="914400" cy="201168"/>
+          </a:xfrm>
+          <a:prstGeom prst="rect">
+            <a:avLst/>
+          </a:prstGeom>
+          <a:noFill/>
+          <a:ln/>
+        </p:spPr>
+        <p:txBody>
+          <a:bodyPr wrap="square" lIns="0" tIns="0" rIns="0" bIns="0" rtlCol="0" anchor="ctr"/>
+          <a:lstStyle/>
+          <a:p>
+            <a:pPr marL="0" indent="0" algn="r">
+              <a:buNone/>
+            </a:pPr>
+            <a:r>
+              <a:rPr lang="en-US" sz="850" dirty="0">
+                <a:solidFill>
+                  <a:srgbClr val="8CA6C0"/>
+                </a:solidFill>
+                <a:latin typeface="Arial" pitchFamily="34" charset="0"/>
+                <a:ea typeface="Arial" pitchFamily="34" charset="-122"/>
+                <a:cs typeface="Arial" pitchFamily="34" charset="-120"/>
+              </a:rPr>
+              <a:t>12 / 18</a:t>
+            </a:r>
+            <a:endParaRPr lang="en-US" sz="850" dirty="0"/>
+          </a:p>
+        </p:txBody>
+      </p:sp>
+    </p:spTree>
+  </p:cSld>
+  <p:clrMapOvr>
+    <a:masterClrMapping/>
+  </p:clrMapOvr>
+  <p:transition spd="slow">
+    <p:push dir="u"/>
+  </p:transition>
+</p:sld>
+</file>
+
+<file path=ppt/slides/slide13.xml><?xml version="1.0" encoding="utf-8"?>
+<p:sld xmlns:a="http://schemas.openxmlformats.org/drawingml/2006/main" xmlns:r="http://schemas.openxmlformats.org/officeDocument/2006/relationships" xmlns:p="http://schemas.openxmlformats.org/presentationml/2006/main">
+  <p:cSld name="Slide 4">
+    <p:bg>
+      <p:bgPr>
+        <a:solidFill>
+          <a:srgbClr val="06101E"/>
+        </a:solidFill>
+        <a:effectLst/>
+      </p:bgPr>
+    </p:bg>
+    <p:spTree>
+      <p:nvGrpSpPr>
+        <p:cNvPr id="1" name=""/>
+        <p:cNvGrpSpPr/>
+        <p:nvPr/>
+      </p:nvGrpSpPr>
+      <p:grpSpPr>
+        <a:xfrm>
+          <a:off x="0" y="0"/>
+          <a:ext cx="0" cy="0"/>
+          <a:chOff x="0" y="0"/>
+          <a:chExt cx="0" cy="0"/>
+        </a:xfrm>
+      </p:grpSpPr>
+      <p:sp>
+        <p:nvSpPr>
+          <p:cNvPr id="2" name="Shape 0"/>
+          <p:cNvSpPr/>
+          <p:nvPr/>
+        </p:nvSpPr>
+        <p:spPr>
+          <a:xfrm>
+            <a:off x="548640" y="461772"/>
+            <a:ext cx="82296" cy="82296"/>
+          </a:xfrm>
+          <a:prstGeom prst="ellipse">
+            <a:avLst/>
+          </a:prstGeom>
+          <a:solidFill>
+            <a:srgbClr val="00D97E"/>
+          </a:solidFill>
+          <a:ln/>
+        </p:spPr>
+        <p:txBody>
+          <a:bodyPr/>
+          <a:lstStyle/>
+          <a:p>
+            <a:endParaRPr lang="sk-SK"/>
+          </a:p>
+        </p:txBody>
+      </p:sp>
+      <p:sp>
+        <p:nvSpPr>
+          <p:cNvPr id="3" name="Text 1"/>
+          <p:cNvSpPr/>
+          <p:nvPr/>
+        </p:nvSpPr>
+        <p:spPr>
+          <a:xfrm>
+            <a:off x="713232" y="402336"/>
+            <a:ext cx="7863840" cy="237744"/>
+          </a:xfrm>
+          <a:prstGeom prst="rect">
+            <a:avLst/>
+          </a:prstGeom>
+          <a:noFill/>
+          <a:ln/>
+        </p:spPr>
+        <p:txBody>
+          <a:bodyPr wrap="square" lIns="0" tIns="0" rIns="0" bIns="0" rtlCol="0" anchor="ctr"/>
+          <a:lstStyle/>
+          <a:p>
+            <a:pPr marL="0" indent="0">
+              <a:buNone/>
+            </a:pPr>
+            <a:r>
+              <a:rPr lang="en-US" sz="1050" b="1" kern="0" spc="320" dirty="0">
+                <a:solidFill>
+                  <a:srgbClr val="00D97E"/>
+                </a:solidFill>
+                <a:latin typeface="Arial" pitchFamily="34" charset="0"/>
+                <a:ea typeface="Arial" pitchFamily="34" charset="-122"/>
+                <a:cs typeface="Arial" pitchFamily="34" charset="-120"/>
+              </a:rPr>
+              <a:t>NAVYŠE Č. 3 — SKAUTING</a:t>
+            </a:r>
+            <a:endParaRPr lang="en-US" sz="1050" dirty="0"/>
+          </a:p>
+        </p:txBody>
+      </p:sp>
+      <p:sp>
+        <p:nvSpPr>
+          <p:cNvPr id="4" name="Text 2"/>
+          <p:cNvSpPr/>
+          <p:nvPr/>
+        </p:nvSpPr>
+        <p:spPr>
+          <a:xfrm>
+            <a:off x="548640" y="676656"/>
+            <a:ext cx="8046720" cy="502920"/>
+          </a:xfrm>
+          <a:prstGeom prst="rect">
+            <a:avLst/>
+          </a:prstGeom>
+          <a:noFill/>
+          <a:ln/>
+        </p:spPr>
+        <p:txBody>
+          <a:bodyPr wrap="square" lIns="0" tIns="0" rIns="0" bIns="0" rtlCol="0" anchor="ctr"/>
+          <a:lstStyle/>
+          <a:p>
+            <a:pPr marL="0" indent="0">
+              <a:buNone/>
+            </a:pPr>
+            <a:r>
+              <a:rPr lang="en-US" sz="2500" b="1" dirty="0">
+                <a:solidFill>
+                  <a:srgbClr val="F1F6FB"/>
+                </a:solidFill>
+                <a:latin typeface="Arial" pitchFamily="34" charset="0"/>
+                <a:ea typeface="Arial" pitchFamily="34" charset="-122"/>
+                <a:cs typeface="Arial" pitchFamily="34" charset="-120"/>
+              </a:rPr>
+              <a:t>Talent viditeľný ďalej než len na tribúne</a:t>
+            </a:r>
+            <a:endParaRPr lang="en-US" sz="2500" dirty="0"/>
+          </a:p>
+        </p:txBody>
+      </p:sp>
+      <p:sp>
+        <p:nvSpPr>
+          <p:cNvPr id="5" name="Text 3"/>
+          <p:cNvSpPr/>
+          <p:nvPr/>
+        </p:nvSpPr>
+        <p:spPr>
+          <a:xfrm>
+            <a:off x="548640" y="1188720"/>
+            <a:ext cx="8046720" cy="320040"/>
+          </a:xfrm>
+          <a:prstGeom prst="rect">
+            <a:avLst/>
+          </a:prstGeom>
+          <a:noFill/>
+          <a:ln/>
+        </p:spPr>
+        <p:txBody>
+          <a:bodyPr wrap="square" lIns="0" tIns="0" rIns="0" bIns="0" rtlCol="0" anchor="ctr"/>
+          <a:lstStyle/>
+          <a:p>
+            <a:pPr marL="0" indent="0">
+              <a:buNone/>
+            </a:pPr>
+            <a:r>
+              <a:rPr lang="en-US" sz="1300" dirty="0">
+                <a:solidFill>
+                  <a:srgbClr val="8CA6C0"/>
+                </a:solidFill>
+                <a:latin typeface="Arial" pitchFamily="34" charset="0"/>
+                <a:ea typeface="Arial" pitchFamily="34" charset="-122"/>
+                <a:cs typeface="Arial" pitchFamily="34" charset="-120"/>
+              </a:rPr>
+              <a:t>Samostatný platený tier pre skautov a agentov — vždy s výslovným súhlasom hráča (a rodiča).</a:t>
+            </a:r>
+            <a:endParaRPr lang="en-US" sz="1300" dirty="0"/>
+          </a:p>
+        </p:txBody>
+      </p:sp>
+      <p:sp>
+        <p:nvSpPr>
+          <p:cNvPr id="6" name="Shape 4"/>
+          <p:cNvSpPr/>
+          <p:nvPr/>
+        </p:nvSpPr>
+        <p:spPr>
+          <a:xfrm>
+            <a:off x="548640" y="1591056"/>
+            <a:ext cx="3886200" cy="1280160"/>
+          </a:xfrm>
+          <a:prstGeom prst="roundRect">
+            <a:avLst>
+              <a:gd name="adj" fmla="val 6429"/>
+            </a:avLst>
+          </a:prstGeom>
+          <a:solidFill>
+            <a:srgbClr val="1A2C42"/>
+          </a:solidFill>
+          <a:ln w="9525">
+            <a:solidFill>
+              <a:srgbClr val="24364D"/>
+            </a:solidFill>
+            <a:prstDash val="solid"/>
+          </a:ln>
+          <a:effectLst>
+            <a:outerShdw blurRad="114300" dist="38100" dir="3600000" algn="bl" rotWithShape="0">
+              <a:srgbClr val="000000">
+                <a:alpha val="35000"/>
+              </a:srgbClr>
+            </a:outerShdw>
+          </a:effectLst>
+        </p:spPr>
+        <p:txBody>
+          <a:bodyPr/>
+          <a:lstStyle/>
+          <a:p>
+            <a:endParaRPr lang="sk-SK"/>
+          </a:p>
+        </p:txBody>
+      </p:sp>
+      <p:sp>
+        <p:nvSpPr>
+          <p:cNvPr id="7" name="Shape 5"/>
+          <p:cNvSpPr/>
+          <p:nvPr/>
+        </p:nvSpPr>
+        <p:spPr>
+          <a:xfrm>
+            <a:off x="749808" y="1737360"/>
+            <a:ext cx="475488" cy="475488"/>
+          </a:xfrm>
+          <a:prstGeom prst="ellipse">
+            <a:avLst/>
+          </a:prstGeom>
+          <a:solidFill>
+            <a:srgbClr val="1A2C42"/>
+          </a:solidFill>
+          <a:ln w="9525">
+            <a:solidFill>
+              <a:srgbClr val="24364D"/>
+            </a:solidFill>
+            <a:prstDash val="solid"/>
+          </a:ln>
+        </p:spPr>
+        <p:txBody>
+          <a:bodyPr/>
+          <a:lstStyle/>
+          <a:p>
+            <a:endParaRPr lang="sk-SK"/>
+          </a:p>
+        </p:txBody>
+      </p:sp>
+      <p:pic>
+        <p:nvPicPr>
+          <p:cNvPr id="8" name="Image 0" descr="preencoded.png"/>
+          <p:cNvPicPr>
+            <a:picLocks noChangeAspect="1"/>
+          </p:cNvPicPr>
+          <p:nvPr/>
+        </p:nvPicPr>
+        <p:blipFill>
+          <a:blip r:embed="rId3"/>
+          <a:stretch>
+            <a:fillRect/>
+          </a:stretch>
+        </p:blipFill>
+        <p:spPr>
+          <a:xfrm>
+            <a:off x="878190" y="1865742"/>
+            <a:ext cx="218724" cy="218724"/>
+          </a:xfrm>
+          <a:prstGeom prst="rect">
+            <a:avLst/>
+          </a:prstGeom>
+        </p:spPr>
+      </p:pic>
+      <p:sp>
+        <p:nvSpPr>
+          <p:cNvPr id="9" name="Text 6"/>
+          <p:cNvSpPr/>
+          <p:nvPr/>
+        </p:nvSpPr>
+        <p:spPr>
+          <a:xfrm>
+            <a:off x="1389888" y="1709928"/>
+            <a:ext cx="2880360" cy="310896"/>
+          </a:xfrm>
+          <a:prstGeom prst="rect">
+            <a:avLst/>
+          </a:prstGeom>
+          <a:noFill/>
+          <a:ln/>
+        </p:spPr>
+        <p:txBody>
+          <a:bodyPr wrap="square" lIns="0" tIns="0" rIns="0" bIns="0" rtlCol="0" anchor="ctr"/>
+          <a:lstStyle/>
+          <a:p>
+            <a:pPr marL="0" indent="0">
+              <a:buNone/>
+            </a:pPr>
+            <a:r>
+              <a:rPr lang="en-US" sz="1450" b="1" dirty="0">
+                <a:solidFill>
+                  <a:srgbClr val="F1F6FB"/>
+                </a:solidFill>
+                <a:latin typeface="Arial" pitchFamily="34" charset="0"/>
+                <a:ea typeface="Arial" pitchFamily="34" charset="-122"/>
+                <a:cs typeface="Arial" pitchFamily="34" charset="-120"/>
+              </a:rPr>
+              <a:t>Súhlas podľa veku</a:t>
+            </a:r>
+            <a:endParaRPr lang="en-US" sz="1450" dirty="0"/>
+          </a:p>
+        </p:txBody>
+      </p:sp>
+      <p:sp>
+        <p:nvSpPr>
+          <p:cNvPr id="10" name="Text 7"/>
+          <p:cNvSpPr/>
+          <p:nvPr/>
+        </p:nvSpPr>
+        <p:spPr>
+          <a:xfrm>
+            <a:off x="1389888" y="2048256"/>
+            <a:ext cx="2834640" cy="731520"/>
+          </a:xfrm>
+          <a:prstGeom prst="rect">
+            <a:avLst/>
+          </a:prstGeom>
+          <a:noFill/>
+          <a:ln/>
+        </p:spPr>
+        <p:txBody>
+          <a:bodyPr wrap="square" lIns="0" tIns="0" rIns="0" bIns="0" rtlCol="0" anchor="ctr"/>
+          <a:lstStyle/>
+          <a:p>
+            <a:pPr marL="0" indent="0">
+              <a:lnSpc>
+                <a:spcPct val="108000"/>
+              </a:lnSpc>
+              <a:buNone/>
+            </a:pPr>
+            <a:r>
+              <a:rPr lang="en-US" sz="1050" dirty="0">
+                <a:solidFill>
+                  <a:srgbClr val="8CA6C0"/>
+                </a:solidFill>
+                <a:latin typeface="Arial" pitchFamily="34" charset="0"/>
+                <a:ea typeface="Arial" pitchFamily="34" charset="-122"/>
+                <a:cs typeface="Arial" pitchFamily="34" charset="-120"/>
+              </a:rPr>
+              <a:t>15+ si hráč sám zapne viditeľnosť pre skautov. Pod 15 rokov naviac potvrdí rodič.</a:t>
+            </a:r>
+            <a:endParaRPr lang="en-US" sz="1050" dirty="0"/>
+          </a:p>
+        </p:txBody>
+      </p:sp>
+      <p:sp>
+        <p:nvSpPr>
+          <p:cNvPr id="11" name="Shape 8"/>
+          <p:cNvSpPr/>
+          <p:nvPr/>
+        </p:nvSpPr>
+        <p:spPr>
+          <a:xfrm>
+            <a:off x="4709160" y="1591056"/>
+            <a:ext cx="3886200" cy="1280160"/>
+          </a:xfrm>
+          <a:prstGeom prst="roundRect">
+            <a:avLst>
+              <a:gd name="adj" fmla="val 6429"/>
+            </a:avLst>
+          </a:prstGeom>
+          <a:solidFill>
+            <a:srgbClr val="1A2C42"/>
+          </a:solidFill>
+          <a:ln w="9525">
+            <a:solidFill>
+              <a:srgbClr val="24364D"/>
+            </a:solidFill>
+            <a:prstDash val="solid"/>
+          </a:ln>
+          <a:effectLst>
+            <a:outerShdw blurRad="114300" dist="38100" dir="3600000" algn="bl" rotWithShape="0">
+              <a:srgbClr val="000000">
+                <a:alpha val="35000"/>
+              </a:srgbClr>
+            </a:outerShdw>
+          </a:effectLst>
+        </p:spPr>
+        <p:txBody>
+          <a:bodyPr/>
+          <a:lstStyle/>
+          <a:p>
+            <a:endParaRPr lang="sk-SK"/>
+          </a:p>
+        </p:txBody>
+      </p:sp>
+      <p:sp>
+        <p:nvSpPr>
+          <p:cNvPr id="12" name="Shape 9"/>
+          <p:cNvSpPr/>
+          <p:nvPr/>
+        </p:nvSpPr>
+        <p:spPr>
+          <a:xfrm>
+            <a:off x="4910328" y="1737360"/>
+            <a:ext cx="475488" cy="475488"/>
+          </a:xfrm>
+          <a:prstGeom prst="ellipse">
+            <a:avLst/>
+          </a:prstGeom>
+          <a:solidFill>
+            <a:srgbClr val="1A2C42"/>
+          </a:solidFill>
+          <a:ln w="9525">
+            <a:solidFill>
+              <a:srgbClr val="24364D"/>
+            </a:solidFill>
+            <a:prstDash val="solid"/>
+          </a:ln>
+        </p:spPr>
+        <p:txBody>
+          <a:bodyPr/>
+          <a:lstStyle/>
+          <a:p>
+            <a:endParaRPr lang="sk-SK"/>
+          </a:p>
+        </p:txBody>
+      </p:sp>
+      <p:pic>
+        <p:nvPicPr>
+          <p:cNvPr id="13" name="Image 1" descr="preencoded.png"/>
+          <p:cNvPicPr>
+            <a:picLocks noChangeAspect="1"/>
+          </p:cNvPicPr>
+          <p:nvPr/>
+        </p:nvPicPr>
+        <p:blipFill>
+          <a:blip r:embed="rId4"/>
+          <a:stretch>
+            <a:fillRect/>
+          </a:stretch>
+        </p:blipFill>
+        <p:spPr>
+          <a:xfrm>
+            <a:off x="5038710" y="1865742"/>
+            <a:ext cx="218724" cy="218724"/>
+          </a:xfrm>
+          <a:prstGeom prst="rect">
+            <a:avLst/>
+          </a:prstGeom>
+        </p:spPr>
+      </p:pic>
+      <p:sp>
+        <p:nvSpPr>
+          <p:cNvPr id="14" name="Text 10"/>
+          <p:cNvSpPr/>
+          <p:nvPr/>
+        </p:nvSpPr>
+        <p:spPr>
+          <a:xfrm>
+            <a:off x="5550408" y="1709928"/>
+            <a:ext cx="2880360" cy="310896"/>
+          </a:xfrm>
+          <a:prstGeom prst="rect">
+            <a:avLst/>
+          </a:prstGeom>
+          <a:noFill/>
+          <a:ln/>
+        </p:spPr>
+        <p:txBody>
+          <a:bodyPr wrap="square" lIns="0" tIns="0" rIns="0" bIns="0" rtlCol="0" anchor="ctr"/>
+          <a:lstStyle/>
+          <a:p>
+            <a:pPr marL="0" indent="0">
+              <a:buNone/>
+            </a:pPr>
+            <a:r>
+              <a:rPr lang="en-US" sz="1450" b="1" dirty="0">
+                <a:solidFill>
+                  <a:srgbClr val="F1F6FB"/>
+                </a:solidFill>
+                <a:latin typeface="Arial" pitchFamily="34" charset="0"/>
+                <a:ea typeface="Arial" pitchFamily="34" charset="-122"/>
+                <a:cs typeface="Arial" pitchFamily="34" charset="-120"/>
+              </a:rPr>
+              <a:t>Čo skaut vidí</a:t>
+            </a:r>
+            <a:endParaRPr lang="en-US" sz="1450" dirty="0"/>
+          </a:p>
+        </p:txBody>
+      </p:sp>
+      <p:sp>
+        <p:nvSpPr>
+          <p:cNvPr id="15" name="Text 11"/>
+          <p:cNvSpPr/>
+          <p:nvPr/>
+        </p:nvSpPr>
+        <p:spPr>
+          <a:xfrm>
+            <a:off x="5550408" y="2048256"/>
+            <a:ext cx="2834640" cy="731520"/>
+          </a:xfrm>
+          <a:prstGeom prst="rect">
+            <a:avLst/>
+          </a:prstGeom>
+          <a:noFill/>
+          <a:ln/>
+        </p:spPr>
+        <p:txBody>
+          <a:bodyPr wrap="square" lIns="0" tIns="0" rIns="0" bIns="0" rtlCol="0" anchor="ctr"/>
+          <a:lstStyle/>
+          <a:p>
+            <a:pPr marL="0" indent="0">
+              <a:lnSpc>
+                <a:spcPct val="108000"/>
+              </a:lnSpc>
+              <a:buNone/>
+            </a:pPr>
+            <a:r>
+              <a:rPr lang="en-US" sz="1050" dirty="0">
+                <a:solidFill>
+                  <a:srgbClr val="8CA6C0"/>
+                </a:solidFill>
+                <a:latin typeface="Arial" pitchFamily="34" charset="0"/>
+                <a:ea typeface="Arial" pitchFamily="34" charset="-122"/>
+                <a:cs typeface="Arial" pitchFamily="34" charset="-120"/>
+              </a:rPr>
+              <a:t>Dochádzka, XP trend, pozápasové hodnotenia, pozícia a kategória — nikdy kontakt ani osobné údaje.</a:t>
+            </a:r>
+            <a:endParaRPr lang="en-US" sz="1050" dirty="0"/>
+          </a:p>
+        </p:txBody>
+      </p:sp>
+      <p:sp>
+        <p:nvSpPr>
+          <p:cNvPr id="16" name="Shape 12"/>
+          <p:cNvSpPr/>
+          <p:nvPr/>
+        </p:nvSpPr>
+        <p:spPr>
+          <a:xfrm>
+            <a:off x="548640" y="2999232"/>
+            <a:ext cx="3886200" cy="1280160"/>
+          </a:xfrm>
+          <a:prstGeom prst="roundRect">
+            <a:avLst>
+              <a:gd name="adj" fmla="val 6429"/>
+            </a:avLst>
+          </a:prstGeom>
+          <a:solidFill>
+            <a:srgbClr val="1A2C42"/>
+          </a:solidFill>
+          <a:ln w="9525">
+            <a:solidFill>
+              <a:srgbClr val="24364D"/>
+            </a:solidFill>
+            <a:prstDash val="solid"/>
+          </a:ln>
+          <a:effectLst>
+            <a:outerShdw blurRad="114300" dist="38100" dir="3600000" algn="bl" rotWithShape="0">
+              <a:srgbClr val="000000">
+                <a:alpha val="35000"/>
+              </a:srgbClr>
+            </a:outerShdw>
+          </a:effectLst>
+        </p:spPr>
+        <p:txBody>
+          <a:bodyPr/>
+          <a:lstStyle/>
+          <a:p>
+            <a:endParaRPr lang="sk-SK"/>
+          </a:p>
+        </p:txBody>
+      </p:sp>
+      <p:sp>
+        <p:nvSpPr>
+          <p:cNvPr id="17" name="Shape 13"/>
+          <p:cNvSpPr/>
+          <p:nvPr/>
+        </p:nvSpPr>
+        <p:spPr>
+          <a:xfrm>
+            <a:off x="749808" y="3145536"/>
+            <a:ext cx="475488" cy="475488"/>
+          </a:xfrm>
+          <a:prstGeom prst="ellipse">
+            <a:avLst/>
+          </a:prstGeom>
+          <a:solidFill>
+            <a:srgbClr val="1A2C42"/>
+          </a:solidFill>
+          <a:ln w="9525">
+            <a:solidFill>
+              <a:srgbClr val="24364D"/>
+            </a:solidFill>
+            <a:prstDash val="solid"/>
+          </a:ln>
+        </p:spPr>
+        <p:txBody>
+          <a:bodyPr/>
+          <a:lstStyle/>
+          <a:p>
+            <a:endParaRPr lang="sk-SK"/>
+          </a:p>
+        </p:txBody>
+      </p:sp>
+      <p:pic>
+        <p:nvPicPr>
+          <p:cNvPr id="18" name="Image 2" descr="preencoded.png"/>
+          <p:cNvPicPr>
+            <a:picLocks noChangeAspect="1"/>
+          </p:cNvPicPr>
+          <p:nvPr/>
+        </p:nvPicPr>
+        <p:blipFill>
+          <a:blip r:embed="rId5"/>
+          <a:stretch>
+            <a:fillRect/>
+          </a:stretch>
+        </p:blipFill>
+        <p:spPr>
+          <a:xfrm>
+            <a:off x="878190" y="3273918"/>
+            <a:ext cx="218724" cy="218724"/>
+          </a:xfrm>
+          <a:prstGeom prst="rect">
+            <a:avLst/>
+          </a:prstGeom>
+        </p:spPr>
+      </p:pic>
+      <p:sp>
+        <p:nvSpPr>
+          <p:cNvPr id="19" name="Text 14"/>
+          <p:cNvSpPr/>
+          <p:nvPr/>
+        </p:nvSpPr>
+        <p:spPr>
+          <a:xfrm>
+            <a:off x="1389888" y="3118104"/>
+            <a:ext cx="2880360" cy="310896"/>
+          </a:xfrm>
+          <a:prstGeom prst="rect">
+            <a:avLst/>
+          </a:prstGeom>
+          <a:noFill/>
+          <a:ln/>
+        </p:spPr>
+        <p:txBody>
+          <a:bodyPr wrap="square" lIns="0" tIns="0" rIns="0" bIns="0" rtlCol="0" anchor="ctr"/>
+          <a:lstStyle/>
+          <a:p>
+            <a:pPr marL="0" indent="0">
+              <a:buNone/>
+            </a:pPr>
+            <a:r>
+              <a:rPr lang="en-US" sz="1450" b="1" dirty="0">
+                <a:solidFill>
+                  <a:srgbClr val="F1F6FB"/>
+                </a:solidFill>
+                <a:latin typeface="Arial" pitchFamily="34" charset="0"/>
+                <a:ea typeface="Arial" pitchFamily="34" charset="-122"/>
+                <a:cs typeface="Arial" pitchFamily="34" charset="-120"/>
+              </a:rPr>
+              <a:t>Kedykoľvek vypnuteľné</a:t>
+            </a:r>
+            <a:endParaRPr lang="en-US" sz="1450" dirty="0"/>
+          </a:p>
+        </p:txBody>
+      </p:sp>
+      <p:sp>
+        <p:nvSpPr>
+          <p:cNvPr id="20" name="Text 15"/>
+          <p:cNvSpPr/>
+          <p:nvPr/>
+        </p:nvSpPr>
+        <p:spPr>
+          <a:xfrm>
+            <a:off x="1389888" y="3456432"/>
+            <a:ext cx="2834640" cy="731520"/>
+          </a:xfrm>
+          <a:prstGeom prst="rect">
+            <a:avLst/>
+          </a:prstGeom>
+          <a:noFill/>
+          <a:ln/>
+        </p:spPr>
+        <p:txBody>
+          <a:bodyPr wrap="square" lIns="0" tIns="0" rIns="0" bIns="0" rtlCol="0" anchor="ctr"/>
+          <a:lstStyle/>
+          <a:p>
+            <a:pPr marL="0" indent="0">
+              <a:lnSpc>
+                <a:spcPct val="108000"/>
+              </a:lnSpc>
+              <a:buNone/>
+            </a:pPr>
+            <a:r>
+              <a:rPr lang="en-US" sz="1050" dirty="0">
+                <a:solidFill>
+                  <a:srgbClr val="8CA6C0"/>
+                </a:solidFill>
+                <a:latin typeface="Arial" pitchFamily="34" charset="0"/>
+                <a:ea typeface="Arial" pitchFamily="34" charset="-122"/>
+                <a:cs typeface="Arial" pitchFamily="34" charset="-120"/>
+              </a:rPr>
+              <a:t>Opt-in je vratný jedným tlačidlom, žiadne uchovávanie u skauta po vypnutí.</a:t>
+            </a:r>
+            <a:endParaRPr lang="en-US" sz="1050" dirty="0"/>
+          </a:p>
+        </p:txBody>
+      </p:sp>
+      <p:sp>
+        <p:nvSpPr>
+          <p:cNvPr id="21" name="Shape 16"/>
+          <p:cNvSpPr/>
+          <p:nvPr/>
+        </p:nvSpPr>
+        <p:spPr>
+          <a:xfrm>
+            <a:off x="4709160" y="2999232"/>
+            <a:ext cx="3886200" cy="1280160"/>
+          </a:xfrm>
+          <a:prstGeom prst="roundRect">
+            <a:avLst>
+              <a:gd name="adj" fmla="val 6429"/>
+            </a:avLst>
+          </a:prstGeom>
+          <a:solidFill>
+            <a:srgbClr val="1A2C42"/>
+          </a:solidFill>
+          <a:ln w="9525">
+            <a:solidFill>
+              <a:srgbClr val="24364D"/>
+            </a:solidFill>
+            <a:prstDash val="solid"/>
+          </a:ln>
+          <a:effectLst>
+            <a:outerShdw blurRad="114300" dist="38100" dir="3600000" algn="bl" rotWithShape="0">
+              <a:srgbClr val="000000">
+                <a:alpha val="35000"/>
+              </a:srgbClr>
+            </a:outerShdw>
+          </a:effectLst>
+        </p:spPr>
+        <p:txBody>
+          <a:bodyPr/>
+          <a:lstStyle/>
+          <a:p>
+            <a:endParaRPr lang="sk-SK"/>
+          </a:p>
+        </p:txBody>
+      </p:sp>
+      <p:sp>
+        <p:nvSpPr>
+          <p:cNvPr id="22" name="Shape 17"/>
+          <p:cNvSpPr/>
+          <p:nvPr/>
+        </p:nvSpPr>
+        <p:spPr>
+          <a:xfrm>
+            <a:off x="4910328" y="3145536"/>
+            <a:ext cx="475488" cy="475488"/>
+          </a:xfrm>
+          <a:prstGeom prst="ellipse">
+            <a:avLst/>
+          </a:prstGeom>
+          <a:solidFill>
+            <a:srgbClr val="1A2C42"/>
+          </a:solidFill>
+          <a:ln w="9525">
+            <a:solidFill>
+              <a:srgbClr val="24364D"/>
+            </a:solidFill>
+            <a:prstDash val="solid"/>
+          </a:ln>
+        </p:spPr>
+        <p:txBody>
+          <a:bodyPr/>
+          <a:lstStyle/>
+          <a:p>
+            <a:endParaRPr lang="sk-SK"/>
+          </a:p>
+        </p:txBody>
+      </p:sp>
+      <p:pic>
+        <p:nvPicPr>
+          <p:cNvPr id="23" name="Image 3" descr="preencoded.png"/>
+          <p:cNvPicPr>
+            <a:picLocks noChangeAspect="1"/>
+          </p:cNvPicPr>
+          <p:nvPr/>
+        </p:nvPicPr>
+        <p:blipFill>
+          <a:blip r:embed="rId6"/>
+          <a:stretch>
+            <a:fillRect/>
+          </a:stretch>
+        </p:blipFill>
+        <p:spPr>
+          <a:xfrm>
+            <a:off x="5038710" y="3273918"/>
+            <a:ext cx="218724" cy="218724"/>
+          </a:xfrm>
+          <a:prstGeom prst="rect">
+            <a:avLst/>
+          </a:prstGeom>
+        </p:spPr>
+      </p:pic>
+      <p:sp>
+        <p:nvSpPr>
+          <p:cNvPr id="24" name="Text 18"/>
+          <p:cNvSpPr/>
+          <p:nvPr/>
+        </p:nvSpPr>
+        <p:spPr>
+          <a:xfrm>
+            <a:off x="5550408" y="3118104"/>
+            <a:ext cx="2880360" cy="310896"/>
+          </a:xfrm>
+          <a:prstGeom prst="rect">
+            <a:avLst/>
+          </a:prstGeom>
+          <a:noFill/>
+          <a:ln/>
+        </p:spPr>
+        <p:txBody>
+          <a:bodyPr wrap="square" lIns="0" tIns="0" rIns="0" bIns="0" rtlCol="0" anchor="ctr"/>
+          <a:lstStyle/>
+          <a:p>
+            <a:pPr marL="0" indent="0">
+              <a:buNone/>
+            </a:pPr>
+            <a:r>
+              <a:rPr lang="en-US" sz="1450" b="1" dirty="0">
+                <a:solidFill>
+                  <a:srgbClr val="F1F6FB"/>
+                </a:solidFill>
+                <a:latin typeface="Arial" pitchFamily="34" charset="0"/>
+                <a:ea typeface="Arial" pitchFamily="34" charset="-122"/>
+                <a:cs typeface="Arial" pitchFamily="34" charset="-120"/>
+              </a:rPr>
+              <a:t>19,99 € / mes.</a:t>
+            </a:r>
+            <a:endParaRPr lang="en-US" sz="1450" dirty="0"/>
+          </a:p>
+        </p:txBody>
+      </p:sp>
+      <p:sp>
+        <p:nvSpPr>
+          <p:cNvPr id="25" name="Text 19"/>
+          <p:cNvSpPr/>
+          <p:nvPr/>
+        </p:nvSpPr>
+        <p:spPr>
+          <a:xfrm>
+            <a:off x="5550408" y="3456432"/>
+            <a:ext cx="2834640" cy="731520"/>
+          </a:xfrm>
+          <a:prstGeom prst="rect">
+            <a:avLst/>
+          </a:prstGeom>
+          <a:noFill/>
+          <a:ln/>
+        </p:spPr>
+        <p:txBody>
+          <a:bodyPr wrap="square" lIns="0" tIns="0" rIns="0" bIns="0" rtlCol="0" anchor="ctr"/>
+          <a:lstStyle/>
+          <a:p>
+            <a:pPr marL="0" indent="0">
+              <a:lnSpc>
+                <a:spcPct val="108000"/>
+              </a:lnSpc>
+              <a:buNone/>
+            </a:pPr>
+            <a:r>
+              <a:rPr lang="en-US" sz="1050" dirty="0">
+                <a:solidFill>
+                  <a:srgbClr val="8CA6C0"/>
+                </a:solidFill>
+                <a:latin typeface="Arial" pitchFamily="34" charset="0"/>
+                <a:ea typeface="Arial" pitchFamily="34" charset="-122"/>
+                <a:cs typeface="Arial" pitchFamily="34" charset="-120"/>
+              </a:rPr>
+              <a:t>Individuálny účet skauta či agenta — žiadna klubová licencia.</a:t>
+            </a:r>
+            <a:endParaRPr lang="en-US" sz="1050" dirty="0"/>
+          </a:p>
+        </p:txBody>
+      </p:sp>
+      <p:sp>
+        <p:nvSpPr>
+          <p:cNvPr id="26" name="Shape 20"/>
+          <p:cNvSpPr/>
+          <p:nvPr/>
+        </p:nvSpPr>
+        <p:spPr>
+          <a:xfrm>
+            <a:off x="548640" y="4370832"/>
+            <a:ext cx="8046720" cy="347472"/>
+          </a:xfrm>
+          <a:prstGeom prst="roundRect">
+            <a:avLst>
+              <a:gd name="adj" fmla="val 50000"/>
+            </a:avLst>
+          </a:prstGeom>
+          <a:solidFill>
+            <a:srgbClr val="0D1B2E"/>
+          </a:solidFill>
+          <a:ln w="12700">
+            <a:solidFill>
+              <a:srgbClr val="00D97E"/>
+            </a:solidFill>
+            <a:prstDash val="solid"/>
+          </a:ln>
+        </p:spPr>
+        <p:txBody>
+          <a:bodyPr/>
+          <a:lstStyle/>
+          <a:p>
+            <a:endParaRPr lang="sk-SK"/>
+          </a:p>
+        </p:txBody>
+      </p:sp>
+      <p:sp>
+        <p:nvSpPr>
+          <p:cNvPr id="27" name="Text 21"/>
+          <p:cNvSpPr/>
+          <p:nvPr/>
+        </p:nvSpPr>
+        <p:spPr>
+          <a:xfrm>
+            <a:off x="822960" y="4370832"/>
+            <a:ext cx="7498080" cy="347472"/>
+          </a:xfrm>
+          <a:prstGeom prst="rect">
+            <a:avLst/>
+          </a:prstGeom>
+          <a:noFill/>
+          <a:ln/>
+        </p:spPr>
+        <p:txBody>
+          <a:bodyPr wrap="square" lIns="0" tIns="0" rIns="0" bIns="0" rtlCol="0" anchor="ctr"/>
+          <a:lstStyle/>
+          <a:p>
+            <a:pPr marL="0" indent="0">
+              <a:buNone/>
+            </a:pPr>
+            <a:r>
+              <a:rPr lang="en-US" sz="1100" b="1" dirty="0">
+                <a:solidFill>
+                  <a:srgbClr val="00D97E"/>
+                </a:solidFill>
+                <a:latin typeface="Arial" pitchFamily="34" charset="0"/>
+                <a:ea typeface="Arial" pitchFamily="34" charset="-122"/>
+                <a:cs typeface="Arial" pitchFamily="34" charset="-120"/>
+              </a:rPr>
+              <a:t>Žiadny nákup bez súhlasu. </a:t>
+            </a:r>
+            <a:r>
+              <a:rPr lang="en-US" sz="1100" dirty="0">
+                <a:solidFill>
+                  <a:srgbClr val="8CA6C0"/>
+                </a:solidFill>
+                <a:latin typeface="Arial" pitchFamily="34" charset="0"/>
+                <a:ea typeface="Arial" pitchFamily="34" charset="-122"/>
+                <a:cs typeface="Arial" pitchFamily="34" charset="-120"/>
+              </a:rPr>
+              <a:t>Hráč aj rodič vidia presne, kto a čo si pozrel.</a:t>
+            </a:r>
+            <a:endParaRPr lang="en-US" sz="1100" dirty="0"/>
+          </a:p>
+        </p:txBody>
+      </p:sp>
+      <p:pic>
+        <p:nvPicPr>
+          <p:cNvPr id="28" name="Image 4" descr="preencoded.png"/>
+          <p:cNvPicPr>
+            <a:picLocks noChangeAspect="1"/>
+          </p:cNvPicPr>
+          <p:nvPr/>
+        </p:nvPicPr>
+        <p:blipFill>
+          <a:blip r:embed="rId7"/>
+          <a:stretch>
+            <a:fillRect/>
+          </a:stretch>
+        </p:blipFill>
+        <p:spPr>
+          <a:xfrm>
+            <a:off x="548640" y="4828032"/>
+            <a:ext cx="155448" cy="155448"/>
+          </a:xfrm>
+          <a:prstGeom prst="rect">
+            <a:avLst/>
+          </a:prstGeom>
+        </p:spPr>
+      </p:pic>
+      <p:sp>
+        <p:nvSpPr>
+          <p:cNvPr id="29" name="Text 22"/>
+          <p:cNvSpPr/>
+          <p:nvPr/>
+        </p:nvSpPr>
+        <p:spPr>
+          <a:xfrm>
+            <a:off x="777240" y="4809744"/>
+            <a:ext cx="3200400" cy="201168"/>
+          </a:xfrm>
+          <a:prstGeom prst="rect">
+            <a:avLst/>
+          </a:prstGeom>
+          <a:noFill/>
+          <a:ln/>
+        </p:spPr>
+        <p:txBody>
+          <a:bodyPr wrap="square" lIns="0" tIns="0" rIns="0" bIns="0" rtlCol="0" anchor="ctr"/>
+          <a:lstStyle/>
+          <a:p>
+            <a:pPr marL="0" indent="0">
+              <a:buNone/>
+            </a:pPr>
+            <a:r>
+              <a:rPr lang="en-US" sz="850" dirty="0">
+                <a:solidFill>
+                  <a:srgbClr val="8CA6C0"/>
+                </a:solidFill>
+                <a:latin typeface="Arial" pitchFamily="34" charset="0"/>
+                <a:ea typeface="Arial" pitchFamily="34" charset="-122"/>
+                <a:cs typeface="Arial" pitchFamily="34" charset="-120"/>
+              </a:rPr>
+              <a:t>fynd.fans — Beyond the Score</a:t>
+            </a:r>
+            <a:endParaRPr lang="en-US" sz="850" dirty="0"/>
+          </a:p>
+        </p:txBody>
+      </p:sp>
+      <p:sp>
+        <p:nvSpPr>
+          <p:cNvPr id="30" name="Text 23"/>
+          <p:cNvSpPr/>
+          <p:nvPr/>
+        </p:nvSpPr>
+        <p:spPr>
+          <a:xfrm>
+            <a:off x="7680960" y="4809744"/>
+            <a:ext cx="914400" cy="201168"/>
+          </a:xfrm>
+          <a:prstGeom prst="rect">
+            <a:avLst/>
+          </a:prstGeom>
+          <a:noFill/>
+          <a:ln/>
+        </p:spPr>
+        <p:txBody>
+          <a:bodyPr wrap="square" lIns="0" tIns="0" rIns="0" bIns="0" rtlCol="0" anchor="ctr"/>
+          <a:lstStyle/>
+          <a:p>
+            <a:pPr marL="0" indent="0" algn="r">
+              <a:buNone/>
+            </a:pPr>
+            <a:r>
+              <a:rPr lang="en-US" sz="850" dirty="0">
+                <a:solidFill>
+                  <a:srgbClr val="8CA6C0"/>
+                </a:solidFill>
+                <a:latin typeface="Arial" pitchFamily="34" charset="0"/>
+                <a:ea typeface="Arial" pitchFamily="34" charset="-122"/>
+                <a:cs typeface="Arial" pitchFamily="34" charset="-120"/>
+              </a:rPr>
+              <a:t>13 / 18</a:t>
+            </a:r>
+            <a:endParaRPr lang="en-US" sz="850" dirty="0"/>
+          </a:p>
+        </p:txBody>
+      </p:sp>
+    </p:spTree>
+  </p:cSld>
+  <p:clrMapOvr>
+    <a:masterClrMapping/>
+  </p:clrMapOvr>
+  <p:transition spd="slow">
+    <p:push dir="u"/>
+  </p:transition>
+</p:sld>
+</file>
+
+<file path=ppt/slides/slide14.xml><?xml version="1.0" encoding="utf-8"?>
+<p:sld xmlns:a="http://schemas.openxmlformats.org/drawingml/2006/main" xmlns:r="http://schemas.openxmlformats.org/officeDocument/2006/relationships" xmlns:p="http://schemas.openxmlformats.org/presentationml/2006/main">
+  <p:cSld name="Slide 4">
+    <p:bg>
+      <p:bgPr>
+        <a:solidFill>
+          <a:srgbClr val="06101E"/>
+        </a:solidFill>
+        <a:effectLst/>
+      </p:bgPr>
+    </p:bg>
+    <p:spTree>
+      <p:nvGrpSpPr>
+        <p:cNvPr id="1" name=""/>
+        <p:cNvGrpSpPr/>
+        <p:nvPr/>
+      </p:nvGrpSpPr>
+      <p:grpSpPr>
+        <a:xfrm>
+          <a:off x="0" y="0"/>
+          <a:ext cx="0" cy="0"/>
+          <a:chOff x="0" y="0"/>
+          <a:chExt cx="0" cy="0"/>
+        </a:xfrm>
+      </p:grpSpPr>
+      <p:sp>
+        <p:nvSpPr>
+          <p:cNvPr id="2" name="Shape 0"/>
+          <p:cNvSpPr/>
+          <p:nvPr/>
+        </p:nvSpPr>
+        <p:spPr>
+          <a:xfrm>
+            <a:off x="548640" y="461772"/>
+            <a:ext cx="82296" cy="82296"/>
+          </a:xfrm>
+          <a:prstGeom prst="ellipse">
+            <a:avLst/>
+          </a:prstGeom>
+          <a:solidFill>
+            <a:srgbClr val="00D97E"/>
+          </a:solidFill>
+          <a:ln/>
+        </p:spPr>
+        <p:txBody>
+          <a:bodyPr/>
+          <a:lstStyle/>
+          <a:p>
+            <a:endParaRPr lang="sk-SK"/>
+          </a:p>
+        </p:txBody>
+      </p:sp>
+      <p:sp>
+        <p:nvSpPr>
+          <p:cNvPr id="3" name="Text 1"/>
+          <p:cNvSpPr/>
+          <p:nvPr/>
+        </p:nvSpPr>
+        <p:spPr>
+          <a:xfrm>
+            <a:off x="713232" y="402336"/>
+            <a:ext cx="7863840" cy="237744"/>
+          </a:xfrm>
+          <a:prstGeom prst="rect">
+            <a:avLst/>
+          </a:prstGeom>
+          <a:noFill/>
+          <a:ln/>
+        </p:spPr>
+        <p:txBody>
+          <a:bodyPr wrap="square" lIns="0" tIns="0" rIns="0" bIns="0" rtlCol="0" anchor="ctr"/>
+          <a:lstStyle/>
+          <a:p>
+            <a:pPr marL="0" indent="0">
+              <a:buNone/>
+            </a:pPr>
+            <a:r>
+              <a:rPr lang="en-US" sz="1050" b="1" kern="0" spc="320" dirty="0">
+                <a:solidFill>
+                  <a:srgbClr val="00D97E"/>
+                </a:solidFill>
+                <a:latin typeface="Arial" pitchFamily="34" charset="0"/>
+                <a:ea typeface="Arial" pitchFamily="34" charset="-122"/>
+                <a:cs typeface="Arial" pitchFamily="34" charset="-120"/>
+              </a:rPr>
+              <a:t>TECHNICKÝ DODATOK</a:t>
+            </a:r>
+            <a:endParaRPr lang="en-US" sz="1050" dirty="0"/>
+          </a:p>
+        </p:txBody>
+      </p:sp>
+      <p:sp>
+        <p:nvSpPr>
+          <p:cNvPr id="4" name="Text 2"/>
+          <p:cNvSpPr/>
+          <p:nvPr/>
+        </p:nvSpPr>
+        <p:spPr>
+          <a:xfrm>
+            <a:off x="548640" y="676656"/>
+            <a:ext cx="8046720" cy="502920"/>
+          </a:xfrm>
+          <a:prstGeom prst="rect">
+            <a:avLst/>
+          </a:prstGeom>
+          <a:noFill/>
+          <a:ln/>
+        </p:spPr>
+        <p:txBody>
+          <a:bodyPr wrap="square" lIns="0" tIns="0" rIns="0" bIns="0" rtlCol="0" anchor="ctr"/>
+          <a:lstStyle/>
+          <a:p>
+            <a:pPr marL="0" indent="0">
+              <a:buNone/>
+            </a:pPr>
+            <a:r>
+              <a:rPr lang="en-US" sz="2500" b="1" dirty="0">
+                <a:solidFill>
+                  <a:srgbClr val="F1F6FB"/>
+                </a:solidFill>
+                <a:latin typeface="Arial" pitchFamily="34" charset="0"/>
+                <a:ea typeface="Arial" pitchFamily="34" charset="-122"/>
+                <a:cs typeface="Arial" pitchFamily="34" charset="-120"/>
+              </a:rPr>
+              <a:t>Ako je to postavené (v skratke)</a:t>
+            </a:r>
+            <a:endParaRPr lang="en-US" sz="2500" dirty="0"/>
+          </a:p>
+        </p:txBody>
+      </p:sp>
+      <p:sp>
+        <p:nvSpPr>
+          <p:cNvPr id="5" name="Text 3"/>
+          <p:cNvSpPr/>
+          <p:nvPr/>
+        </p:nvSpPr>
+        <p:spPr>
+          <a:xfrm>
+            <a:off x="548640" y="1188720"/>
+            <a:ext cx="8046720" cy="320040"/>
+          </a:xfrm>
+          <a:prstGeom prst="rect">
+            <a:avLst/>
+          </a:prstGeom>
+          <a:noFill/>
+          <a:ln/>
+        </p:spPr>
+        <p:txBody>
+          <a:bodyPr wrap="square" lIns="0" tIns="0" rIns="0" bIns="0" rtlCol="0" anchor="ctr"/>
+          <a:lstStyle/>
+          <a:p>
+            <a:pPr marL="0" indent="0">
+              <a:buNone/>
+            </a:pPr>
+            <a:r>
+              <a:rPr lang="en-US" sz="1300" dirty="0">
+                <a:solidFill>
+                  <a:srgbClr val="8CA6C0"/>
+                </a:solidFill>
+                <a:latin typeface="Arial" pitchFamily="34" charset="0"/>
+                <a:ea typeface="Arial" pitchFamily="34" charset="-122"/>
+                <a:cs typeface="Arial" pitchFamily="34" charset="-120"/>
+              </a:rPr>
+              <a:t>Plný technický popis je verejne v repozitári — tu len prehľad pre kontext.</a:t>
+            </a:r>
+            <a:endParaRPr lang="en-US" sz="1300" dirty="0"/>
+          </a:p>
+        </p:txBody>
+      </p:sp>
+      <p:sp>
+        <p:nvSpPr>
+          <p:cNvPr id="6" name="Shape 4"/>
+          <p:cNvSpPr/>
+          <p:nvPr/>
+        </p:nvSpPr>
+        <p:spPr>
+          <a:xfrm>
+            <a:off x="548640" y="1591056"/>
+            <a:ext cx="3886200" cy="1280160"/>
+          </a:xfrm>
+          <a:prstGeom prst="roundRect">
+            <a:avLst>
+              <a:gd name="adj" fmla="val 6429"/>
+            </a:avLst>
+          </a:prstGeom>
+          <a:solidFill>
+            <a:srgbClr val="1A2C42"/>
+          </a:solidFill>
+          <a:ln w="9525">
+            <a:solidFill>
+              <a:srgbClr val="24364D"/>
+            </a:solidFill>
+            <a:prstDash val="solid"/>
+          </a:ln>
+          <a:effectLst>
+            <a:outerShdw blurRad="114300" dist="38100" dir="3600000" algn="bl" rotWithShape="0">
+              <a:srgbClr val="000000">
+                <a:alpha val="35000"/>
+              </a:srgbClr>
+            </a:outerShdw>
+          </a:effectLst>
+        </p:spPr>
+        <p:txBody>
+          <a:bodyPr/>
+          <a:lstStyle/>
+          <a:p>
+            <a:endParaRPr lang="sk-SK"/>
+          </a:p>
+        </p:txBody>
+      </p:sp>
+      <p:sp>
+        <p:nvSpPr>
+          <p:cNvPr id="7" name="Shape 5"/>
+          <p:cNvSpPr/>
+          <p:nvPr/>
+        </p:nvSpPr>
+        <p:spPr>
+          <a:xfrm>
+            <a:off x="749808" y="1737360"/>
+            <a:ext cx="475488" cy="475488"/>
+          </a:xfrm>
+          <a:prstGeom prst="ellipse">
+            <a:avLst/>
+          </a:prstGeom>
+          <a:solidFill>
+            <a:srgbClr val="1A2C42"/>
+          </a:solidFill>
+          <a:ln w="9525">
+            <a:solidFill>
+              <a:srgbClr val="24364D"/>
+            </a:solidFill>
+            <a:prstDash val="solid"/>
+          </a:ln>
+        </p:spPr>
+        <p:txBody>
+          <a:bodyPr/>
+          <a:lstStyle/>
+          <a:p>
+            <a:endParaRPr lang="sk-SK"/>
+          </a:p>
+        </p:txBody>
+      </p:sp>
+      <p:pic>
+        <p:nvPicPr>
+          <p:cNvPr id="8" name="Image 0" descr="preencoded.png"/>
+          <p:cNvPicPr>
+            <a:picLocks noChangeAspect="1"/>
+          </p:cNvPicPr>
+          <p:nvPr/>
+        </p:nvPicPr>
+        <p:blipFill>
+          <a:blip r:embed="rId3"/>
+          <a:stretch>
+            <a:fillRect/>
+          </a:stretch>
+        </p:blipFill>
+        <p:spPr>
+          <a:xfrm>
+            <a:off x="878190" y="1865742"/>
+            <a:ext cx="218724" cy="218724"/>
+          </a:xfrm>
+          <a:prstGeom prst="rect">
+            <a:avLst/>
+          </a:prstGeom>
+        </p:spPr>
+      </p:pic>
+      <p:sp>
+        <p:nvSpPr>
+          <p:cNvPr id="9" name="Text 6"/>
+          <p:cNvSpPr/>
+          <p:nvPr/>
+        </p:nvSpPr>
+        <p:spPr>
+          <a:xfrm>
+            <a:off x="1389888" y="1709928"/>
+            <a:ext cx="2880360" cy="310896"/>
+          </a:xfrm>
+          <a:prstGeom prst="rect">
+            <a:avLst/>
+          </a:prstGeom>
+          <a:noFill/>
+          <a:ln/>
+        </p:spPr>
+        <p:txBody>
+          <a:bodyPr wrap="square" lIns="0" tIns="0" rIns="0" bIns="0" rtlCol="0" anchor="ctr"/>
+          <a:lstStyle/>
+          <a:p>
+            <a:pPr marL="0" indent="0">
+              <a:buNone/>
+            </a:pPr>
+            <a:r>
+              <a:rPr lang="en-US" sz="1450" b="1" dirty="0">
+                <a:solidFill>
+                  <a:srgbClr val="F1F6FB"/>
+                </a:solidFill>
+                <a:latin typeface="Arial" pitchFamily="34" charset="0"/>
+                <a:ea typeface="Arial" pitchFamily="34" charset="-122"/>
+                <a:cs typeface="Arial" pitchFamily="34" charset="-120"/>
+              </a:rPr>
+              <a:t>Frontend</a:t>
+            </a:r>
+            <a:endParaRPr lang="en-US" sz="1450" dirty="0"/>
+          </a:p>
+        </p:txBody>
+      </p:sp>
+      <p:sp>
+        <p:nvSpPr>
+          <p:cNvPr id="10" name="Text 7"/>
+          <p:cNvSpPr/>
+          <p:nvPr/>
+        </p:nvSpPr>
+        <p:spPr>
+          <a:xfrm>
+            <a:off x="1389888" y="2048256"/>
+            <a:ext cx="2834640" cy="731520"/>
+          </a:xfrm>
+          <a:prstGeom prst="rect">
+            <a:avLst/>
+          </a:prstGeom>
+          <a:noFill/>
+          <a:ln/>
+        </p:spPr>
+        <p:txBody>
+          <a:bodyPr wrap="square" lIns="0" tIns="0" rIns="0" bIns="0" rtlCol="0" anchor="ctr"/>
+          <a:lstStyle/>
+          <a:p>
+            <a:pPr marL="0" indent="0">
+              <a:lnSpc>
+                <a:spcPct val="108000"/>
+              </a:lnSpc>
+              <a:buNone/>
+            </a:pPr>
+            <a:r>
+              <a:rPr lang="en-US" sz="1050" dirty="0">
+                <a:solidFill>
+                  <a:srgbClr val="8CA6C0"/>
+                </a:solidFill>
+                <a:latin typeface="Arial" pitchFamily="34" charset="0"/>
+                <a:ea typeface="Arial" pitchFamily="34" charset="-122"/>
+                <a:cs typeface="Arial" pitchFamily="34" charset="-120"/>
+              </a:rPr>
+              <a:t>Progressive Web App — React, TypeScript, Tailwind. Bez povinného App Store.</a:t>
+            </a:r>
+            <a:endParaRPr lang="en-US" sz="1050" dirty="0"/>
+          </a:p>
+        </p:txBody>
+      </p:sp>
+      <p:sp>
+        <p:nvSpPr>
+          <p:cNvPr id="11" name="Shape 8"/>
+          <p:cNvSpPr/>
+          <p:nvPr/>
+        </p:nvSpPr>
+        <p:spPr>
+          <a:xfrm>
+            <a:off x="4709160" y="1591056"/>
+            <a:ext cx="3886200" cy="1280160"/>
+          </a:xfrm>
+          <a:prstGeom prst="roundRect">
+            <a:avLst>
+              <a:gd name="adj" fmla="val 6429"/>
+            </a:avLst>
+          </a:prstGeom>
+          <a:solidFill>
+            <a:srgbClr val="1A2C42"/>
+          </a:solidFill>
+          <a:ln w="9525">
+            <a:solidFill>
+              <a:srgbClr val="24364D"/>
+            </a:solidFill>
+            <a:prstDash val="solid"/>
+          </a:ln>
+          <a:effectLst>
+            <a:outerShdw blurRad="114300" dist="38100" dir="3600000" algn="bl" rotWithShape="0">
+              <a:srgbClr val="000000">
+                <a:alpha val="35000"/>
+              </a:srgbClr>
+            </a:outerShdw>
+          </a:effectLst>
+        </p:spPr>
+        <p:txBody>
+          <a:bodyPr/>
+          <a:lstStyle/>
+          <a:p>
+            <a:endParaRPr lang="sk-SK"/>
+          </a:p>
+        </p:txBody>
+      </p:sp>
+      <p:sp>
+        <p:nvSpPr>
+          <p:cNvPr id="12" name="Shape 9"/>
+          <p:cNvSpPr/>
+          <p:nvPr/>
+        </p:nvSpPr>
+        <p:spPr>
+          <a:xfrm>
+            <a:off x="4910328" y="1737360"/>
+            <a:ext cx="475488" cy="475488"/>
+          </a:xfrm>
+          <a:prstGeom prst="ellipse">
+            <a:avLst/>
+          </a:prstGeom>
+          <a:solidFill>
+            <a:srgbClr val="1A2C42"/>
+          </a:solidFill>
+          <a:ln w="9525">
+            <a:solidFill>
+              <a:srgbClr val="24364D"/>
+            </a:solidFill>
+            <a:prstDash val="solid"/>
+          </a:ln>
+        </p:spPr>
+        <p:txBody>
+          <a:bodyPr/>
+          <a:lstStyle/>
+          <a:p>
+            <a:endParaRPr lang="sk-SK"/>
+          </a:p>
+        </p:txBody>
+      </p:sp>
+      <p:pic>
+        <p:nvPicPr>
+          <p:cNvPr id="13" name="Image 1" descr="preencoded.png"/>
+          <p:cNvPicPr>
+            <a:picLocks noChangeAspect="1"/>
+          </p:cNvPicPr>
+          <p:nvPr/>
+        </p:nvPicPr>
+        <p:blipFill>
+          <a:blip r:embed="rId4"/>
+          <a:stretch>
+            <a:fillRect/>
+          </a:stretch>
+        </p:blipFill>
+        <p:spPr>
+          <a:xfrm>
+            <a:off x="5038710" y="1865742"/>
+            <a:ext cx="218724" cy="218724"/>
+          </a:xfrm>
+          <a:prstGeom prst="rect">
+            <a:avLst/>
+          </a:prstGeom>
+        </p:spPr>
+      </p:pic>
+      <p:sp>
+        <p:nvSpPr>
+          <p:cNvPr id="14" name="Text 10"/>
+          <p:cNvSpPr/>
+          <p:nvPr/>
+        </p:nvSpPr>
+        <p:spPr>
+          <a:xfrm>
+            <a:off x="5550408" y="1709928"/>
+            <a:ext cx="2880360" cy="310896"/>
+          </a:xfrm>
+          <a:prstGeom prst="rect">
+            <a:avLst/>
+          </a:prstGeom>
+          <a:noFill/>
+          <a:ln/>
+        </p:spPr>
+        <p:txBody>
+          <a:bodyPr wrap="square" lIns="0" tIns="0" rIns="0" bIns="0" rtlCol="0" anchor="ctr"/>
+          <a:lstStyle/>
+          <a:p>
+            <a:pPr marL="0" indent="0">
+              <a:buNone/>
+            </a:pPr>
+            <a:r>
+              <a:rPr lang="en-US" sz="1450" b="1" dirty="0">
+                <a:solidFill>
+                  <a:srgbClr val="F1F6FB"/>
+                </a:solidFill>
+                <a:latin typeface="Arial" pitchFamily="34" charset="0"/>
+                <a:ea typeface="Arial" pitchFamily="34" charset="-122"/>
+                <a:cs typeface="Arial" pitchFamily="34" charset="-120"/>
+              </a:rPr>
+              <a:t>Backend</a:t>
+            </a:r>
+            <a:endParaRPr lang="en-US" sz="1450" dirty="0"/>
+          </a:p>
+        </p:txBody>
+      </p:sp>
+      <p:sp>
+        <p:nvSpPr>
+          <p:cNvPr id="15" name="Text 11"/>
+          <p:cNvSpPr/>
+          <p:nvPr/>
+        </p:nvSpPr>
+        <p:spPr>
+          <a:xfrm>
+            <a:off x="5550408" y="2048256"/>
+            <a:ext cx="2834640" cy="731520"/>
+          </a:xfrm>
+          <a:prstGeom prst="rect">
+            <a:avLst/>
+          </a:prstGeom>
+          <a:noFill/>
+          <a:ln/>
+        </p:spPr>
+        <p:txBody>
+          <a:bodyPr wrap="square" lIns="0" tIns="0" rIns="0" bIns="0" rtlCol="0" anchor="ctr"/>
+          <a:lstStyle/>
+          <a:p>
+            <a:pPr marL="0" indent="0">
+              <a:lnSpc>
+                <a:spcPct val="108000"/>
+              </a:lnSpc>
+              <a:buNone/>
+            </a:pPr>
+            <a:r>
+              <a:rPr lang="en-US" sz="1050" dirty="0">
+                <a:solidFill>
+                  <a:srgbClr val="8CA6C0"/>
+                </a:solidFill>
+                <a:latin typeface="Arial" pitchFamily="34" charset="0"/>
+                <a:ea typeface="Arial" pitchFamily="34" charset="-122"/>
+                <a:cs typeface="Arial" pitchFamily="34" charset="-120"/>
+              </a:rPr>
+              <a:t>Node.js + Express, TypeScript. Rýchlejšie MVP: Supabase.</a:t>
+            </a:r>
+            <a:endParaRPr lang="en-US" sz="1050" dirty="0"/>
+          </a:p>
+        </p:txBody>
+      </p:sp>
+      <p:sp>
+        <p:nvSpPr>
+          <p:cNvPr id="16" name="Shape 12"/>
+          <p:cNvSpPr/>
+          <p:nvPr/>
+        </p:nvSpPr>
+        <p:spPr>
+          <a:xfrm>
+            <a:off x="548640" y="2999232"/>
+            <a:ext cx="3886200" cy="1280160"/>
+          </a:xfrm>
+          <a:prstGeom prst="roundRect">
+            <a:avLst>
+              <a:gd name="adj" fmla="val 6429"/>
+            </a:avLst>
+          </a:prstGeom>
+          <a:solidFill>
+            <a:srgbClr val="1A2C42"/>
+          </a:solidFill>
+          <a:ln w="9525">
+            <a:solidFill>
+              <a:srgbClr val="24364D"/>
+            </a:solidFill>
+            <a:prstDash val="solid"/>
+          </a:ln>
+          <a:effectLst>
+            <a:outerShdw blurRad="114300" dist="38100" dir="3600000" algn="bl" rotWithShape="0">
+              <a:srgbClr val="000000">
+                <a:alpha val="35000"/>
+              </a:srgbClr>
+            </a:outerShdw>
+          </a:effectLst>
+        </p:spPr>
+        <p:txBody>
+          <a:bodyPr/>
+          <a:lstStyle/>
+          <a:p>
+            <a:endParaRPr lang="sk-SK"/>
+          </a:p>
+        </p:txBody>
+      </p:sp>
+      <p:sp>
+        <p:nvSpPr>
+          <p:cNvPr id="17" name="Shape 13"/>
+          <p:cNvSpPr/>
+          <p:nvPr/>
+        </p:nvSpPr>
+        <p:spPr>
+          <a:xfrm>
+            <a:off x="749808" y="3145536"/>
+            <a:ext cx="475488" cy="475488"/>
+          </a:xfrm>
+          <a:prstGeom prst="ellipse">
+            <a:avLst/>
+          </a:prstGeom>
+          <a:solidFill>
+            <a:srgbClr val="1A2C42"/>
+          </a:solidFill>
+          <a:ln w="9525">
+            <a:solidFill>
+              <a:srgbClr val="24364D"/>
+            </a:solidFill>
+            <a:prstDash val="solid"/>
+          </a:ln>
+        </p:spPr>
+        <p:txBody>
+          <a:bodyPr/>
+          <a:lstStyle/>
+          <a:p>
+            <a:endParaRPr lang="sk-SK"/>
+          </a:p>
+        </p:txBody>
+      </p:sp>
+      <p:pic>
+        <p:nvPicPr>
+          <p:cNvPr id="18" name="Image 2" descr="preencoded.png"/>
+          <p:cNvPicPr>
+            <a:picLocks noChangeAspect="1"/>
+          </p:cNvPicPr>
+          <p:nvPr/>
+        </p:nvPicPr>
+        <p:blipFill>
+          <a:blip r:embed="rId5"/>
+          <a:stretch>
+            <a:fillRect/>
+          </a:stretch>
+        </p:blipFill>
+        <p:spPr>
+          <a:xfrm>
+            <a:off x="878190" y="3273918"/>
+            <a:ext cx="218724" cy="218724"/>
+          </a:xfrm>
+          <a:prstGeom prst="rect">
+            <a:avLst/>
+          </a:prstGeom>
+        </p:spPr>
+      </p:pic>
+      <p:sp>
+        <p:nvSpPr>
+          <p:cNvPr id="19" name="Text 14"/>
+          <p:cNvSpPr/>
+          <p:nvPr/>
+        </p:nvSpPr>
+        <p:spPr>
+          <a:xfrm>
+            <a:off x="1389888" y="3118104"/>
+            <a:ext cx="2880360" cy="310896"/>
+          </a:xfrm>
+          <a:prstGeom prst="rect">
+            <a:avLst/>
+          </a:prstGeom>
+          <a:noFill/>
+          <a:ln/>
+        </p:spPr>
+        <p:txBody>
+          <a:bodyPr wrap="square" lIns="0" tIns="0" rIns="0" bIns="0" rtlCol="0" anchor="ctr"/>
+          <a:lstStyle/>
+          <a:p>
+            <a:pPr marL="0" indent="0">
+              <a:buNone/>
+            </a:pPr>
+            <a:r>
+              <a:rPr lang="en-US" sz="1450" b="1" dirty="0">
+                <a:solidFill>
+                  <a:srgbClr val="F1F6FB"/>
+                </a:solidFill>
+                <a:latin typeface="Arial" pitchFamily="34" charset="0"/>
+                <a:ea typeface="Arial" pitchFamily="34" charset="-122"/>
+                <a:cs typeface="Arial" pitchFamily="34" charset="-120"/>
+              </a:rPr>
+              <a:t>Databáza</a:t>
+            </a:r>
+            <a:endParaRPr lang="en-US" sz="1450" dirty="0"/>
+          </a:p>
+        </p:txBody>
+      </p:sp>
+      <p:sp>
+        <p:nvSpPr>
+          <p:cNvPr id="20" name="Text 15"/>
+          <p:cNvSpPr/>
+          <p:nvPr/>
+        </p:nvSpPr>
+        <p:spPr>
+          <a:xfrm>
+            <a:off x="1389888" y="3456432"/>
+            <a:ext cx="2834640" cy="731520"/>
+          </a:xfrm>
+          <a:prstGeom prst="rect">
+            <a:avLst/>
+          </a:prstGeom>
+          <a:noFill/>
+          <a:ln/>
+        </p:spPr>
+        <p:txBody>
+          <a:bodyPr wrap="square" lIns="0" tIns="0" rIns="0" bIns="0" rtlCol="0" anchor="ctr"/>
+          <a:lstStyle/>
+          <a:p>
+            <a:pPr marL="0" indent="0">
+              <a:lnSpc>
+                <a:spcPct val="108000"/>
+              </a:lnSpc>
+              <a:buNone/>
+            </a:pPr>
+            <a:r>
+              <a:rPr lang="en-US" sz="1050" dirty="0">
+                <a:solidFill>
+                  <a:srgbClr val="8CA6C0"/>
+                </a:solidFill>
+                <a:latin typeface="Arial" pitchFamily="34" charset="0"/>
+                <a:ea typeface="Arial" pitchFamily="34" charset="-122"/>
+                <a:cs typeface="Arial" pitchFamily="34" charset="-120"/>
+              </a:rPr>
+              <a:t>PostgreSQL — hráči, kluby, tréningy, XP udalosti, odznaky, Odmeňovňa, skautský opt-in.</a:t>
+            </a:r>
+            <a:endParaRPr lang="en-US" sz="1050" dirty="0"/>
+          </a:p>
+        </p:txBody>
+      </p:sp>
+      <p:sp>
+        <p:nvSpPr>
+          <p:cNvPr id="21" name="Shape 16"/>
+          <p:cNvSpPr/>
+          <p:nvPr/>
+        </p:nvSpPr>
+        <p:spPr>
+          <a:xfrm>
+            <a:off x="4709160" y="2999232"/>
+            <a:ext cx="3886200" cy="1280160"/>
+          </a:xfrm>
+          <a:prstGeom prst="roundRect">
+            <a:avLst>
+              <a:gd name="adj" fmla="val 6429"/>
+            </a:avLst>
+          </a:prstGeom>
+          <a:solidFill>
+            <a:srgbClr val="1A2C42"/>
+          </a:solidFill>
+          <a:ln w="9525">
+            <a:solidFill>
+              <a:srgbClr val="24364D"/>
+            </a:solidFill>
+            <a:prstDash val="solid"/>
+          </a:ln>
+          <a:effectLst>
+            <a:outerShdw blurRad="114300" dist="38100" dir="3600000" algn="bl" rotWithShape="0">
+              <a:srgbClr val="000000">
+                <a:alpha val="35000"/>
+              </a:srgbClr>
+            </a:outerShdw>
+          </a:effectLst>
+        </p:spPr>
+        <p:txBody>
+          <a:bodyPr/>
+          <a:lstStyle/>
+          <a:p>
+            <a:endParaRPr lang="sk-SK"/>
+          </a:p>
+        </p:txBody>
+      </p:sp>
+      <p:sp>
+        <p:nvSpPr>
+          <p:cNvPr id="22" name="Shape 17"/>
+          <p:cNvSpPr/>
+          <p:nvPr/>
+        </p:nvSpPr>
+        <p:spPr>
+          <a:xfrm>
+            <a:off x="4910328" y="3145536"/>
+            <a:ext cx="475488" cy="475488"/>
+          </a:xfrm>
+          <a:prstGeom prst="ellipse">
+            <a:avLst/>
+          </a:prstGeom>
+          <a:solidFill>
+            <a:srgbClr val="1A2C42"/>
+          </a:solidFill>
+          <a:ln w="9525">
+            <a:solidFill>
+              <a:srgbClr val="24364D"/>
+            </a:solidFill>
+            <a:prstDash val="solid"/>
+          </a:ln>
+        </p:spPr>
+        <p:txBody>
+          <a:bodyPr/>
+          <a:lstStyle/>
+          <a:p>
+            <a:endParaRPr lang="sk-SK"/>
+          </a:p>
+        </p:txBody>
+      </p:sp>
+      <p:pic>
+        <p:nvPicPr>
+          <p:cNvPr id="23" name="Image 3" descr="preencoded.png"/>
+          <p:cNvPicPr>
+            <a:picLocks noChangeAspect="1"/>
+          </p:cNvPicPr>
+          <p:nvPr/>
+        </p:nvPicPr>
+        <p:blipFill>
+          <a:blip r:embed="rId6"/>
+          <a:stretch>
+            <a:fillRect/>
+          </a:stretch>
+        </p:blipFill>
+        <p:spPr>
+          <a:xfrm>
+            <a:off x="5038710" y="3273918"/>
+            <a:ext cx="218724" cy="218724"/>
+          </a:xfrm>
+          <a:prstGeom prst="rect">
+            <a:avLst/>
+          </a:prstGeom>
+        </p:spPr>
+      </p:pic>
+      <p:sp>
+        <p:nvSpPr>
+          <p:cNvPr id="24" name="Text 18"/>
+          <p:cNvSpPr/>
+          <p:nvPr/>
+        </p:nvSpPr>
+        <p:spPr>
+          <a:xfrm>
+            <a:off x="5550408" y="3118104"/>
+            <a:ext cx="2880360" cy="310896"/>
+          </a:xfrm>
+          <a:prstGeom prst="rect">
+            <a:avLst/>
+          </a:prstGeom>
+          <a:noFill/>
+          <a:ln/>
+        </p:spPr>
+        <p:txBody>
+          <a:bodyPr wrap="square" lIns="0" tIns="0" rIns="0" bIns="0" rtlCol="0" anchor="ctr"/>
+          <a:lstStyle/>
+          <a:p>
+            <a:pPr marL="0" indent="0">
+              <a:buNone/>
+            </a:pPr>
+            <a:r>
+              <a:rPr lang="en-US" sz="1450" b="1" dirty="0">
+                <a:solidFill>
+                  <a:srgbClr val="F1F6FB"/>
+                </a:solidFill>
+                <a:latin typeface="Arial" pitchFamily="34" charset="0"/>
+                <a:ea typeface="Arial" pitchFamily="34" charset="-122"/>
+                <a:cs typeface="Arial" pitchFamily="34" charset="-120"/>
+              </a:rPr>
+              <a:t>Kde nájsť viac</a:t>
+            </a:r>
+            <a:endParaRPr lang="en-US" sz="1450" dirty="0"/>
+          </a:p>
+        </p:txBody>
+      </p:sp>
+      <p:sp>
+        <p:nvSpPr>
+          <p:cNvPr id="25" name="Text 19"/>
+          <p:cNvSpPr/>
+          <p:nvPr/>
+        </p:nvSpPr>
+        <p:spPr>
+          <a:xfrm>
+            <a:off x="5550408" y="3456432"/>
+            <a:ext cx="2834640" cy="731520"/>
+          </a:xfrm>
+          <a:prstGeom prst="rect">
+            <a:avLst/>
+          </a:prstGeom>
+          <a:noFill/>
+          <a:ln/>
+        </p:spPr>
+        <p:txBody>
+          <a:bodyPr wrap="square" lIns="0" tIns="0" rIns="0" bIns="0" rtlCol="0" anchor="ctr"/>
+          <a:lstStyle/>
+          <a:p>
+            <a:pPr marL="0" indent="0">
+              <a:lnSpc>
+                <a:spcPct val="108000"/>
+              </a:lnSpc>
+              <a:buNone/>
+            </a:pPr>
+            <a:r>
+              <a:rPr lang="en-US" sz="1050" dirty="0">
+                <a:solidFill>
+                  <a:srgbClr val="8CA6C0"/>
+                </a:solidFill>
+                <a:latin typeface="Arial" pitchFamily="34" charset="0"/>
+                <a:ea typeface="Arial" pitchFamily="34" charset="-122"/>
+                <a:cs typeface="Arial" pitchFamily="34" charset="-120"/>
+              </a:rPr>
+              <a:t>docs/tech-stack.md, docs/premium-profiles.md — github.com/tadawur/fynd</a:t>
+            </a:r>
+            <a:endParaRPr lang="en-US" sz="1050" dirty="0"/>
+          </a:p>
+        </p:txBody>
+      </p:sp>
+      <p:sp>
+        <p:nvSpPr>
+          <p:cNvPr id="26" name="Shape 20"/>
+          <p:cNvSpPr/>
+          <p:nvPr/>
+        </p:nvSpPr>
+        <p:spPr>
+          <a:xfrm>
+            <a:off x="548640" y="4370832"/>
+            <a:ext cx="8046720" cy="347472"/>
+          </a:xfrm>
+          <a:prstGeom prst="roundRect">
+            <a:avLst>
+              <a:gd name="adj" fmla="val 50000"/>
+            </a:avLst>
+          </a:prstGeom>
+          <a:solidFill>
+            <a:srgbClr val="0D1B2E"/>
+          </a:solidFill>
+          <a:ln w="12700">
+            <a:solidFill>
+              <a:srgbClr val="00D97E"/>
+            </a:solidFill>
+            <a:prstDash val="solid"/>
+          </a:ln>
+        </p:spPr>
+        <p:txBody>
+          <a:bodyPr/>
+          <a:lstStyle/>
+          <a:p>
+            <a:endParaRPr lang="sk-SK"/>
+          </a:p>
+        </p:txBody>
+      </p:sp>
+      <p:sp>
+        <p:nvSpPr>
+          <p:cNvPr id="27" name="Text 21"/>
+          <p:cNvSpPr/>
+          <p:nvPr/>
+        </p:nvSpPr>
+        <p:spPr>
+          <a:xfrm>
+            <a:off x="822960" y="4370832"/>
+            <a:ext cx="7498080" cy="347472"/>
+          </a:xfrm>
+          <a:prstGeom prst="rect">
+            <a:avLst/>
+          </a:prstGeom>
+          <a:noFill/>
+          <a:ln/>
+        </p:spPr>
+        <p:txBody>
+          <a:bodyPr wrap="square" lIns="0" tIns="0" rIns="0" bIns="0" rtlCol="0" anchor="ctr"/>
+          <a:lstStyle/>
+          <a:p>
+            <a:pPr marL="0" indent="0">
+              <a:buNone/>
+            </a:pPr>
+            <a:r>
+              <a:rPr lang="en-US" sz="1100" b="1" dirty="0">
+                <a:solidFill>
+                  <a:srgbClr val="00D97E"/>
+                </a:solidFill>
+                <a:latin typeface="Arial" pitchFamily="34" charset="0"/>
+                <a:ea typeface="Arial" pitchFamily="34" charset="-122"/>
+                <a:cs typeface="Arial" pitchFamily="34" charset="-120"/>
+              </a:rPr>
+              <a:t>Žiadny vendor lock-in. </a:t>
+            </a:r>
+            <a:r>
+              <a:rPr lang="en-US" sz="1100" dirty="0">
+                <a:solidFill>
+                  <a:srgbClr val="8CA6C0"/>
+                </a:solidFill>
+                <a:latin typeface="Arial" pitchFamily="34" charset="0"/>
+                <a:ea typeface="Arial" pitchFamily="34" charset="-122"/>
+                <a:cs typeface="Arial" pitchFamily="34" charset="-120"/>
+              </a:rPr>
+              <a:t>Bežné open-source technológie, jednoducho nahraditeľné a auditovateľné.</a:t>
+            </a:r>
+            <a:endParaRPr lang="en-US" sz="1100" dirty="0"/>
+          </a:p>
+        </p:txBody>
+      </p:sp>
+      <p:pic>
+        <p:nvPicPr>
+          <p:cNvPr id="28" name="Image 4" descr="preencoded.png"/>
+          <p:cNvPicPr>
+            <a:picLocks noChangeAspect="1"/>
+          </p:cNvPicPr>
+          <p:nvPr/>
+        </p:nvPicPr>
+        <p:blipFill>
+          <a:blip r:embed="rId7"/>
+          <a:stretch>
+            <a:fillRect/>
+          </a:stretch>
+        </p:blipFill>
+        <p:spPr>
+          <a:xfrm>
+            <a:off x="548640" y="4828032"/>
+            <a:ext cx="155448" cy="155448"/>
+          </a:xfrm>
+          <a:prstGeom prst="rect">
+            <a:avLst/>
+          </a:prstGeom>
+        </p:spPr>
+      </p:pic>
+      <p:sp>
+        <p:nvSpPr>
+          <p:cNvPr id="29" name="Text 22"/>
+          <p:cNvSpPr/>
+          <p:nvPr/>
+        </p:nvSpPr>
+        <p:spPr>
+          <a:xfrm>
+            <a:off x="777240" y="4809744"/>
+            <a:ext cx="3200400" cy="201168"/>
+          </a:xfrm>
+          <a:prstGeom prst="rect">
+            <a:avLst/>
+          </a:prstGeom>
+          <a:noFill/>
+          <a:ln/>
+        </p:spPr>
+        <p:txBody>
+          <a:bodyPr wrap="square" lIns="0" tIns="0" rIns="0" bIns="0" rtlCol="0" anchor="ctr"/>
+          <a:lstStyle/>
+          <a:p>
+            <a:pPr marL="0" indent="0">
+              <a:buNone/>
+            </a:pPr>
+            <a:r>
+              <a:rPr lang="en-US" sz="850" dirty="0">
+                <a:solidFill>
+                  <a:srgbClr val="8CA6C0"/>
+                </a:solidFill>
+                <a:latin typeface="Arial" pitchFamily="34" charset="0"/>
+                <a:ea typeface="Arial" pitchFamily="34" charset="-122"/>
+                <a:cs typeface="Arial" pitchFamily="34" charset="-120"/>
+              </a:rPr>
+              <a:t>fynd.fans — Beyond the Score</a:t>
+            </a:r>
+            <a:endParaRPr lang="en-US" sz="850" dirty="0"/>
+          </a:p>
+        </p:txBody>
+      </p:sp>
+      <p:sp>
+        <p:nvSpPr>
+          <p:cNvPr id="30" name="Text 23"/>
+          <p:cNvSpPr/>
+          <p:nvPr/>
+        </p:nvSpPr>
+        <p:spPr>
+          <a:xfrm>
+            <a:off x="7680960" y="4809744"/>
+            <a:ext cx="914400" cy="201168"/>
+          </a:xfrm>
+          <a:prstGeom prst="rect">
+            <a:avLst/>
+          </a:prstGeom>
+          <a:noFill/>
+          <a:ln/>
+        </p:spPr>
+        <p:txBody>
+          <a:bodyPr wrap="square" lIns="0" tIns="0" rIns="0" bIns="0" rtlCol="0" anchor="ctr"/>
+          <a:lstStyle/>
+          <a:p>
+            <a:pPr marL="0" indent="0" algn="r">
+              <a:buNone/>
+            </a:pPr>
+            <a:r>
+              <a:rPr lang="en-US" sz="850" dirty="0">
+                <a:solidFill>
+                  <a:srgbClr val="8CA6C0"/>
+                </a:solidFill>
+                <a:latin typeface="Arial" pitchFamily="34" charset="0"/>
+                <a:ea typeface="Arial" pitchFamily="34" charset="-122"/>
+                <a:cs typeface="Arial" pitchFamily="34" charset="-120"/>
+              </a:rPr>
+              <a:t>14 / 18</a:t>
+            </a:r>
+            <a:endParaRPr lang="en-US" sz="850" dirty="0"/>
+          </a:p>
+        </p:txBody>
+      </p:sp>
+    </p:spTree>
+  </p:cSld>
+  <p:clrMapOvr>
+    <a:masterClrMapping/>
+  </p:clrMapOvr>
+  <p:transition spd="slow">
+    <p:push dir="u"/>
+  </p:transition>
+</p:sld>
+</file>
+
+<file path=ppt/slides/slide15.xml><?xml version="1.0" encoding="utf-8"?>
+<p:sld xmlns:a="http://schemas.openxmlformats.org/drawingml/2006/main" xmlns:r="http://schemas.openxmlformats.org/officeDocument/2006/relationships" xmlns:p="http://schemas.openxmlformats.org/presentationml/2006/main">
+  <p:cSld name="Slide 4">
+    <p:bg>
+      <p:bgPr>
+        <a:solidFill>
+          <a:srgbClr val="06101E"/>
+        </a:solidFill>
+        <a:effectLst/>
+      </p:bgPr>
+    </p:bg>
+    <p:spTree>
+      <p:nvGrpSpPr>
+        <p:cNvPr id="1" name=""/>
+        <p:cNvGrpSpPr/>
+        <p:nvPr/>
+      </p:nvGrpSpPr>
+      <p:grpSpPr>
+        <a:xfrm>
+          <a:off x="0" y="0"/>
+          <a:ext cx="0" cy="0"/>
+          <a:chOff x="0" y="0"/>
+          <a:chExt cx="0" cy="0"/>
+        </a:xfrm>
+      </p:grpSpPr>
+      <p:sp>
+        <p:nvSpPr>
+          <p:cNvPr id="2" name="Shape 0"/>
+          <p:cNvSpPr/>
+          <p:nvPr/>
+        </p:nvSpPr>
+        <p:spPr>
+          <a:xfrm>
+            <a:off x="548640" y="461772"/>
+            <a:ext cx="82296" cy="82296"/>
+          </a:xfrm>
+          <a:prstGeom prst="ellipse">
+            <a:avLst/>
+          </a:prstGeom>
+          <a:solidFill>
+            <a:srgbClr val="00D97E"/>
+          </a:solidFill>
+          <a:ln/>
+        </p:spPr>
+        <p:txBody>
+          <a:bodyPr/>
+          <a:lstStyle/>
+          <a:p>
+            <a:endParaRPr lang="sk-SK"/>
+          </a:p>
+        </p:txBody>
+      </p:sp>
+      <p:sp>
+        <p:nvSpPr>
+          <p:cNvPr id="3" name="Text 1"/>
+          <p:cNvSpPr/>
+          <p:nvPr/>
+        </p:nvSpPr>
+        <p:spPr>
+          <a:xfrm>
+            <a:off x="713232" y="402336"/>
+            <a:ext cx="7863840" cy="237744"/>
+          </a:xfrm>
+          <a:prstGeom prst="rect">
+            <a:avLst/>
+          </a:prstGeom>
+          <a:noFill/>
+          <a:ln/>
+        </p:spPr>
+        <p:txBody>
+          <a:bodyPr wrap="square" lIns="0" tIns="0" rIns="0" bIns="0" rtlCol="0" anchor="ctr"/>
+          <a:lstStyle/>
+          <a:p>
+            <a:pPr marL="0" indent="0">
+              <a:buNone/>
+            </a:pPr>
+            <a:r>
+              <a:rPr lang="en-US" sz="1050" b="1" kern="0" spc="320" dirty="0">
+                <a:solidFill>
+                  <a:srgbClr val="00D97E"/>
+                </a:solidFill>
+                <a:latin typeface="Arial" pitchFamily="34" charset="0"/>
+                <a:ea typeface="Arial" pitchFamily="34" charset="-122"/>
+                <a:cs typeface="Arial" pitchFamily="34" charset="-120"/>
+              </a:rPr>
+              <a:t>ŠKÁLOVANIE A NÁKLADY</a:t>
+            </a:r>
+            <a:endParaRPr lang="en-US" sz="1050" dirty="0"/>
+          </a:p>
+        </p:txBody>
+      </p:sp>
+      <p:sp>
+        <p:nvSpPr>
+          <p:cNvPr id="4" name="Text 2"/>
+          <p:cNvSpPr/>
+          <p:nvPr/>
+        </p:nvSpPr>
+        <p:spPr>
+          <a:xfrm>
+            <a:off x="548640" y="676656"/>
+            <a:ext cx="8046720" cy="502920"/>
+          </a:xfrm>
+          <a:prstGeom prst="rect">
+            <a:avLst/>
+          </a:prstGeom>
+          <a:noFill/>
+          <a:ln/>
+        </p:spPr>
+        <p:txBody>
+          <a:bodyPr wrap="square" lIns="0" tIns="0" rIns="0" bIns="0" rtlCol="0" anchor="ctr"/>
+          <a:lstStyle/>
+          <a:p>
+            <a:pPr marL="0" indent="0">
+              <a:buNone/>
+            </a:pPr>
+            <a:r>
+              <a:rPr lang="en-US" sz="2500" b="1" dirty="0">
+                <a:solidFill>
+                  <a:srgbClr val="F1F6FB"/>
+                </a:solidFill>
+                <a:latin typeface="Arial" pitchFamily="34" charset="0"/>
+                <a:ea typeface="Arial" pitchFamily="34" charset="-122"/>
+                <a:cs typeface="Arial" pitchFamily="34" charset="-120"/>
+              </a:rPr>
+              <a:t>100–200-tisíc ročne? Rovnaký stack, iné čísla</a:t>
+            </a:r>
+            <a:endParaRPr lang="en-US" sz="2500" dirty="0"/>
+          </a:p>
+        </p:txBody>
+      </p:sp>
+      <p:sp>
+        <p:nvSpPr>
+          <p:cNvPr id="5" name="Text 3"/>
+          <p:cNvSpPr/>
+          <p:nvPr/>
+        </p:nvSpPr>
+        <p:spPr>
+          <a:xfrm>
+            <a:off x="548640" y="1188720"/>
+            <a:ext cx="8046720" cy="320040"/>
+          </a:xfrm>
+          <a:prstGeom prst="rect">
+            <a:avLst/>
+          </a:prstGeom>
+          <a:noFill/>
+          <a:ln/>
+        </p:spPr>
+        <p:txBody>
+          <a:bodyPr wrap="square" lIns="0" tIns="0" rIns="0" bIns="0" rtlCol="0" anchor="ctr"/>
+          <a:lstStyle/>
+          <a:p>
+            <a:pPr marL="0" indent="0">
+              <a:buNone/>
+            </a:pPr>
+            <a:r>
+              <a:rPr lang="en-US" sz="1300" dirty="0">
+                <a:solidFill>
+                  <a:srgbClr val="8CA6C0"/>
+                </a:solidFill>
+                <a:latin typeface="Arial" pitchFamily="34" charset="0"/>
+                <a:ea typeface="Arial" pitchFamily="34" charset="-122"/>
+                <a:cs typeface="Arial" pitchFamily="34" charset="-120"/>
+              </a:rPr>
+              <a:t>Ilustračný odhad pri národnom rozsahu — plný rozpis v docs/FINANCIALS.md.</a:t>
+            </a:r>
+            <a:endParaRPr lang="en-US" sz="1300" dirty="0"/>
+          </a:p>
+        </p:txBody>
+      </p:sp>
+      <p:sp>
+        <p:nvSpPr>
+          <p:cNvPr id="6" name="Shape 4"/>
+          <p:cNvSpPr/>
+          <p:nvPr/>
+        </p:nvSpPr>
+        <p:spPr>
+          <a:xfrm>
+            <a:off x="548640" y="1591056"/>
+            <a:ext cx="3886200" cy="1280160"/>
+          </a:xfrm>
+          <a:prstGeom prst="roundRect">
+            <a:avLst>
+              <a:gd name="adj" fmla="val 6429"/>
+            </a:avLst>
+          </a:prstGeom>
+          <a:solidFill>
+            <a:srgbClr val="1A2C42"/>
+          </a:solidFill>
+          <a:ln w="9525">
+            <a:solidFill>
+              <a:srgbClr val="24364D"/>
+            </a:solidFill>
+            <a:prstDash val="solid"/>
+          </a:ln>
+          <a:effectLst>
+            <a:outerShdw blurRad="114300" dist="38100" dir="3600000" algn="bl" rotWithShape="0">
+              <a:srgbClr val="000000">
+                <a:alpha val="35000"/>
+              </a:srgbClr>
+            </a:outerShdw>
+          </a:effectLst>
+        </p:spPr>
+        <p:txBody>
+          <a:bodyPr/>
+          <a:lstStyle/>
+          <a:p>
+            <a:endParaRPr lang="sk-SK"/>
+          </a:p>
+        </p:txBody>
+      </p:sp>
+      <p:sp>
+        <p:nvSpPr>
+          <p:cNvPr id="7" name="Shape 5"/>
+          <p:cNvSpPr/>
+          <p:nvPr/>
+        </p:nvSpPr>
+        <p:spPr>
+          <a:xfrm>
+            <a:off x="749808" y="1737360"/>
+            <a:ext cx="475488" cy="475488"/>
+          </a:xfrm>
+          <a:prstGeom prst="ellipse">
+            <a:avLst/>
+          </a:prstGeom>
+          <a:solidFill>
+            <a:srgbClr val="1A2C42"/>
+          </a:solidFill>
+          <a:ln w="9525">
+            <a:solidFill>
+              <a:srgbClr val="24364D"/>
+            </a:solidFill>
+            <a:prstDash val="solid"/>
+          </a:ln>
+        </p:spPr>
+        <p:txBody>
+          <a:bodyPr/>
+          <a:lstStyle/>
+          <a:p>
+            <a:endParaRPr lang="sk-SK"/>
+          </a:p>
+        </p:txBody>
+      </p:sp>
+      <p:pic>
+        <p:nvPicPr>
+          <p:cNvPr id="8" name="Image 0" descr="preencoded.png"/>
+          <p:cNvPicPr>
+            <a:picLocks noChangeAspect="1"/>
+          </p:cNvPicPr>
+          <p:nvPr/>
+        </p:nvPicPr>
+        <p:blipFill>
+          <a:blip r:embed="rId3"/>
+          <a:stretch>
+            <a:fillRect/>
+          </a:stretch>
+        </p:blipFill>
+        <p:spPr>
+          <a:xfrm>
+            <a:off x="878190" y="1865742"/>
+            <a:ext cx="218724" cy="218724"/>
+          </a:xfrm>
+          <a:prstGeom prst="rect">
+            <a:avLst/>
+          </a:prstGeom>
+        </p:spPr>
+      </p:pic>
+      <p:sp>
+        <p:nvSpPr>
+          <p:cNvPr id="9" name="Text 6"/>
+          <p:cNvSpPr/>
+          <p:nvPr/>
+        </p:nvSpPr>
+        <p:spPr>
+          <a:xfrm>
+            <a:off x="1389888" y="1709928"/>
+            <a:ext cx="2880360" cy="310896"/>
+          </a:xfrm>
+          <a:prstGeom prst="rect">
+            <a:avLst/>
+          </a:prstGeom>
+          <a:noFill/>
+          <a:ln/>
+        </p:spPr>
+        <p:txBody>
+          <a:bodyPr wrap="square" lIns="0" tIns="0" rIns="0" bIns="0" rtlCol="0" anchor="ctr"/>
+          <a:lstStyle/>
+          <a:p>
+            <a:pPr marL="0" indent="0">
+              <a:buNone/>
+            </a:pPr>
+            <a:r>
+              <a:rPr lang="en-US" sz="1450" b="1" dirty="0">
+                <a:solidFill>
+                  <a:srgbClr val="F1F6FB"/>
+                </a:solidFill>
+                <a:latin typeface="Arial" pitchFamily="34" charset="0"/>
+                <a:ea typeface="Arial" pitchFamily="34" charset="-122"/>
+                <a:cs typeface="Arial" pitchFamily="34" charset="-120"/>
+              </a:rPr>
+              <a:t>Rovnaký stack, viac kapacity</a:t>
+            </a:r>
+            <a:endParaRPr lang="en-US" sz="1450" dirty="0"/>
+          </a:p>
+        </p:txBody>
+      </p:sp>
+      <p:sp>
+        <p:nvSpPr>
+          <p:cNvPr id="10" name="Text 7"/>
+          <p:cNvSpPr/>
+          <p:nvPr/>
+        </p:nvSpPr>
+        <p:spPr>
+          <a:xfrm>
+            <a:off x="1389888" y="2048256"/>
+            <a:ext cx="2834640" cy="731520"/>
+          </a:xfrm>
+          <a:prstGeom prst="rect">
+            <a:avLst/>
+          </a:prstGeom>
+          <a:noFill/>
+          <a:ln/>
+        </p:spPr>
+        <p:txBody>
+          <a:bodyPr wrap="square" lIns="0" tIns="0" rIns="0" bIns="0" rtlCol="0" anchor="ctr"/>
+          <a:lstStyle/>
+          <a:p>
+            <a:pPr marL="0" indent="0">
+              <a:lnSpc>
+                <a:spcPct val="108000"/>
+              </a:lnSpc>
+              <a:buNone/>
+            </a:pPr>
+            <a:r>
+              <a:rPr lang="en-US" sz="1050" dirty="0">
+                <a:solidFill>
+                  <a:srgbClr val="8CA6C0"/>
+                </a:solidFill>
+                <a:latin typeface="Arial" pitchFamily="34" charset="0"/>
+                <a:ea typeface="Arial" pitchFamily="34" charset="-122"/>
+                <a:cs typeface="Arial" pitchFamily="34" charset="-120"/>
+              </a:rPr>
+              <a:t>Žiadna prestavba — len read replika databázy, viac backend inštancií a vyšší CDN tier.</a:t>
+            </a:r>
+            <a:endParaRPr lang="en-US" sz="1050" dirty="0"/>
+          </a:p>
+        </p:txBody>
+      </p:sp>
+      <p:sp>
+        <p:nvSpPr>
+          <p:cNvPr id="11" name="Shape 8"/>
+          <p:cNvSpPr/>
+          <p:nvPr/>
+        </p:nvSpPr>
+        <p:spPr>
+          <a:xfrm>
+            <a:off x="4709160" y="1591056"/>
+            <a:ext cx="3886200" cy="1280160"/>
+          </a:xfrm>
+          <a:prstGeom prst="roundRect">
+            <a:avLst>
+              <a:gd name="adj" fmla="val 6429"/>
+            </a:avLst>
+          </a:prstGeom>
+          <a:solidFill>
+            <a:srgbClr val="1A2C42"/>
+          </a:solidFill>
+          <a:ln w="9525">
+            <a:solidFill>
+              <a:srgbClr val="24364D"/>
+            </a:solidFill>
+            <a:prstDash val="solid"/>
+          </a:ln>
+          <a:effectLst>
+            <a:outerShdw blurRad="114300" dist="38100" dir="3600000" algn="bl" rotWithShape="0">
+              <a:srgbClr val="000000">
+                <a:alpha val="35000"/>
+              </a:srgbClr>
+            </a:outerShdw>
+          </a:effectLst>
+        </p:spPr>
+        <p:txBody>
+          <a:bodyPr/>
+          <a:lstStyle/>
+          <a:p>
+            <a:endParaRPr lang="sk-SK"/>
+          </a:p>
+        </p:txBody>
+      </p:sp>
+      <p:sp>
+        <p:nvSpPr>
+          <p:cNvPr id="12" name="Shape 9"/>
+          <p:cNvSpPr/>
+          <p:nvPr/>
+        </p:nvSpPr>
+        <p:spPr>
+          <a:xfrm>
+            <a:off x="4910328" y="1737360"/>
+            <a:ext cx="475488" cy="475488"/>
+          </a:xfrm>
+          <a:prstGeom prst="ellipse">
+            <a:avLst/>
+          </a:prstGeom>
+          <a:solidFill>
+            <a:srgbClr val="1A2C42"/>
+          </a:solidFill>
+          <a:ln w="9525">
+            <a:solidFill>
+              <a:srgbClr val="24364D"/>
+            </a:solidFill>
+            <a:prstDash val="solid"/>
+          </a:ln>
+        </p:spPr>
+        <p:txBody>
+          <a:bodyPr/>
+          <a:lstStyle/>
+          <a:p>
+            <a:endParaRPr lang="sk-SK"/>
+          </a:p>
+        </p:txBody>
+      </p:sp>
+      <p:pic>
+        <p:nvPicPr>
+          <p:cNvPr id="13" name="Image 1" descr="preencoded.png"/>
+          <p:cNvPicPr>
+            <a:picLocks noChangeAspect="1"/>
+          </p:cNvPicPr>
+          <p:nvPr/>
+        </p:nvPicPr>
+        <p:blipFill>
+          <a:blip r:embed="rId4"/>
+          <a:stretch>
+            <a:fillRect/>
+          </a:stretch>
+        </p:blipFill>
+        <p:spPr>
+          <a:xfrm>
+            <a:off x="5038710" y="1865742"/>
+            <a:ext cx="218724" cy="218724"/>
+          </a:xfrm>
+          <a:prstGeom prst="rect">
+            <a:avLst/>
+          </a:prstGeom>
+        </p:spPr>
+      </p:pic>
+      <p:sp>
+        <p:nvSpPr>
+          <p:cNvPr id="14" name="Text 10"/>
+          <p:cNvSpPr/>
+          <p:nvPr/>
+        </p:nvSpPr>
+        <p:spPr>
+          <a:xfrm>
+            <a:off x="5550408" y="1709928"/>
+            <a:ext cx="2880360" cy="310896"/>
+          </a:xfrm>
+          <a:prstGeom prst="rect">
+            <a:avLst/>
+          </a:prstGeom>
+          <a:noFill/>
+          <a:ln/>
+        </p:spPr>
+        <p:txBody>
+          <a:bodyPr wrap="square" lIns="0" tIns="0" rIns="0" bIns="0" rtlCol="0" anchor="ctr"/>
+          <a:lstStyle/>
+          <a:p>
+            <a:pPr marL="0" indent="0">
+              <a:buNone/>
+            </a:pPr>
+            <a:r>
+              <a:rPr lang="en-US" sz="1450" b="1" dirty="0">
+                <a:solidFill>
+                  <a:srgbClr val="F1F6FB"/>
+                </a:solidFill>
+                <a:latin typeface="Arial" pitchFamily="34" charset="0"/>
+                <a:ea typeface="Arial" pitchFamily="34" charset="-122"/>
+                <a:cs typeface="Arial" pitchFamily="34" charset="-120"/>
+              </a:rPr>
+              <a:t>Infraštruktúra: ~650 – 1 100 € / mes.</a:t>
+            </a:r>
+            <a:endParaRPr lang="en-US" sz="1450" dirty="0"/>
+          </a:p>
+        </p:txBody>
+      </p:sp>
+      <p:sp>
+        <p:nvSpPr>
+          <p:cNvPr id="15" name="Text 11"/>
+          <p:cNvSpPr/>
+          <p:nvPr/>
+        </p:nvSpPr>
+        <p:spPr>
+          <a:xfrm>
+            <a:off x="5550408" y="2048256"/>
+            <a:ext cx="2834640" cy="731520"/>
+          </a:xfrm>
+          <a:prstGeom prst="rect">
+            <a:avLst/>
+          </a:prstGeom>
+          <a:noFill/>
+          <a:ln/>
+        </p:spPr>
+        <p:txBody>
+          <a:bodyPr wrap="square" lIns="0" tIns="0" rIns="0" bIns="0" rtlCol="0" anchor="ctr"/>
+          <a:lstStyle/>
+          <a:p>
+            <a:pPr marL="0" indent="0">
+              <a:lnSpc>
+                <a:spcPct val="108000"/>
+              </a:lnSpc>
+              <a:buNone/>
+            </a:pPr>
+            <a:r>
+              <a:rPr lang="en-US" sz="1050" dirty="0">
+                <a:solidFill>
+                  <a:srgbClr val="8CA6C0"/>
+                </a:solidFill>
+                <a:latin typeface="Arial" pitchFamily="34" charset="0"/>
+                <a:ea typeface="Arial" pitchFamily="34" charset="-122"/>
+                <a:cs typeface="Arial" pitchFamily="34" charset="-120"/>
+              </a:rPr>
+              <a:t>DB, cache, storage, monitoring pri 200-tis. používateľoch — 2× oproti 10-tisícovej škále, nie 20×.</a:t>
+            </a:r>
+            <a:endParaRPr lang="en-US" sz="1050" dirty="0"/>
+          </a:p>
+        </p:txBody>
+      </p:sp>
+      <p:sp>
+        <p:nvSpPr>
+          <p:cNvPr id="16" name="Shape 12"/>
+          <p:cNvSpPr/>
+          <p:nvPr/>
+        </p:nvSpPr>
+        <p:spPr>
+          <a:xfrm>
+            <a:off x="548640" y="2999232"/>
+            <a:ext cx="3886200" cy="1280160"/>
+          </a:xfrm>
+          <a:prstGeom prst="roundRect">
+            <a:avLst>
+              <a:gd name="adj" fmla="val 6429"/>
+            </a:avLst>
+          </a:prstGeom>
+          <a:solidFill>
+            <a:srgbClr val="1A2C42"/>
+          </a:solidFill>
+          <a:ln w="9525">
+            <a:solidFill>
+              <a:srgbClr val="24364D"/>
+            </a:solidFill>
+            <a:prstDash val="solid"/>
+          </a:ln>
+          <a:effectLst>
+            <a:outerShdw blurRad="114300" dist="38100" dir="3600000" algn="bl" rotWithShape="0">
+              <a:srgbClr val="000000">
+                <a:alpha val="35000"/>
+              </a:srgbClr>
+            </a:outerShdw>
+          </a:effectLst>
+        </p:spPr>
+        <p:txBody>
+          <a:bodyPr/>
+          <a:lstStyle/>
+          <a:p>
+            <a:endParaRPr lang="sk-SK"/>
+          </a:p>
+        </p:txBody>
+      </p:sp>
+      <p:sp>
+        <p:nvSpPr>
+          <p:cNvPr id="17" name="Shape 13"/>
+          <p:cNvSpPr/>
+          <p:nvPr/>
+        </p:nvSpPr>
+        <p:spPr>
+          <a:xfrm>
+            <a:off x="749808" y="3145536"/>
+            <a:ext cx="475488" cy="475488"/>
+          </a:xfrm>
+          <a:prstGeom prst="ellipse">
+            <a:avLst/>
+          </a:prstGeom>
+          <a:solidFill>
+            <a:srgbClr val="1A2C42"/>
+          </a:solidFill>
+          <a:ln w="9525">
+            <a:solidFill>
+              <a:srgbClr val="24364D"/>
+            </a:solidFill>
+            <a:prstDash val="solid"/>
+          </a:ln>
+        </p:spPr>
+        <p:txBody>
+          <a:bodyPr/>
+          <a:lstStyle/>
+          <a:p>
+            <a:endParaRPr lang="sk-SK"/>
+          </a:p>
+        </p:txBody>
+      </p:sp>
+      <p:pic>
+        <p:nvPicPr>
+          <p:cNvPr id="18" name="Image 2" descr="preencoded.png"/>
+          <p:cNvPicPr>
+            <a:picLocks noChangeAspect="1"/>
+          </p:cNvPicPr>
+          <p:nvPr/>
+        </p:nvPicPr>
+        <p:blipFill>
+          <a:blip r:embed="rId5"/>
+          <a:stretch>
+            <a:fillRect/>
+          </a:stretch>
+        </p:blipFill>
+        <p:spPr>
+          <a:xfrm>
+            <a:off x="878190" y="3273918"/>
+            <a:ext cx="218724" cy="218724"/>
+          </a:xfrm>
+          <a:prstGeom prst="rect">
+            <a:avLst/>
+          </a:prstGeom>
+        </p:spPr>
+      </p:pic>
+      <p:sp>
+        <p:nvSpPr>
+          <p:cNvPr id="19" name="Text 14"/>
+          <p:cNvSpPr/>
+          <p:nvPr/>
+        </p:nvSpPr>
+        <p:spPr>
+          <a:xfrm>
+            <a:off x="1389888" y="3118104"/>
+            <a:ext cx="2880360" cy="310896"/>
+          </a:xfrm>
+          <a:prstGeom prst="rect">
+            <a:avLst/>
+          </a:prstGeom>
+          <a:noFill/>
+          <a:ln/>
+        </p:spPr>
+        <p:txBody>
+          <a:bodyPr wrap="square" lIns="0" tIns="0" rIns="0" bIns="0" rtlCol="0" anchor="ctr"/>
+          <a:lstStyle/>
+          <a:p>
+            <a:pPr marL="0" indent="0">
+              <a:buNone/>
+            </a:pPr>
+            <a:r>
+              <a:rPr lang="en-US" sz="1450" b="1" dirty="0">
+                <a:solidFill>
+                  <a:srgbClr val="F1F6FB"/>
+                </a:solidFill>
+                <a:latin typeface="Arial" pitchFamily="34" charset="0"/>
+                <a:ea typeface="Arial" pitchFamily="34" charset="-122"/>
+                <a:cs typeface="Arial" pitchFamily="34" charset="-120"/>
+              </a:rPr>
+              <a:t>Treba už tím, nie len zakladateľa</a:t>
+            </a:r>
+            <a:endParaRPr lang="en-US" sz="1450" dirty="0"/>
+          </a:p>
+        </p:txBody>
+      </p:sp>
+      <p:sp>
+        <p:nvSpPr>
+          <p:cNvPr id="20" name="Text 15"/>
+          <p:cNvSpPr/>
+          <p:nvPr/>
+        </p:nvSpPr>
+        <p:spPr>
+          <a:xfrm>
+            <a:off x="1389888" y="3456432"/>
+            <a:ext cx="2834640" cy="731520"/>
+          </a:xfrm>
+          <a:prstGeom prst="rect">
+            <a:avLst/>
+          </a:prstGeom>
+          <a:noFill/>
+          <a:ln/>
+        </p:spPr>
+        <p:txBody>
+          <a:bodyPr wrap="square" lIns="0" tIns="0" rIns="0" bIns="0" rtlCol="0" anchor="ctr"/>
+          <a:lstStyle/>
+          <a:p>
+            <a:pPr marL="0" indent="0">
+              <a:lnSpc>
+                <a:spcPct val="108000"/>
+              </a:lnSpc>
+              <a:buNone/>
+            </a:pPr>
+            <a:r>
+              <a:rPr lang="en-US" sz="1050" dirty="0">
+                <a:solidFill>
+                  <a:srgbClr val="8CA6C0"/>
+                </a:solidFill>
+                <a:latin typeface="Arial" pitchFamily="34" charset="0"/>
+                <a:ea typeface="Arial" pitchFamily="34" charset="-122"/>
+                <a:cs typeface="Arial" pitchFamily="34" charset="-120"/>
+              </a:rPr>
+              <a:t>Aspoň 1 človek na čiastočný úväzok pre DevOps a SLA — odhad 800 – 1 500 € / mes.</a:t>
+            </a:r>
+            <a:endParaRPr lang="en-US" sz="1050" dirty="0"/>
+          </a:p>
+        </p:txBody>
+      </p:sp>
+      <p:sp>
+        <p:nvSpPr>
+          <p:cNvPr id="21" name="Shape 16"/>
+          <p:cNvSpPr/>
+          <p:nvPr/>
+        </p:nvSpPr>
+        <p:spPr>
+          <a:xfrm>
+            <a:off x="4709160" y="2999232"/>
+            <a:ext cx="3886200" cy="1280160"/>
+          </a:xfrm>
+          <a:prstGeom prst="roundRect">
+            <a:avLst>
+              <a:gd name="adj" fmla="val 6429"/>
+            </a:avLst>
+          </a:prstGeom>
+          <a:solidFill>
+            <a:srgbClr val="1A2C42"/>
+          </a:solidFill>
+          <a:ln w="9525">
+            <a:solidFill>
+              <a:srgbClr val="24364D"/>
+            </a:solidFill>
+            <a:prstDash val="solid"/>
+          </a:ln>
+          <a:effectLst>
+            <a:outerShdw blurRad="114300" dist="38100" dir="3600000" algn="bl" rotWithShape="0">
+              <a:srgbClr val="000000">
+                <a:alpha val="35000"/>
+              </a:srgbClr>
+            </a:outerShdw>
+          </a:effectLst>
+        </p:spPr>
+        <p:txBody>
+          <a:bodyPr/>
+          <a:lstStyle/>
+          <a:p>
+            <a:endParaRPr lang="sk-SK"/>
+          </a:p>
+        </p:txBody>
+      </p:sp>
+      <p:sp>
+        <p:nvSpPr>
+          <p:cNvPr id="22" name="Shape 17"/>
+          <p:cNvSpPr/>
+          <p:nvPr/>
+        </p:nvSpPr>
+        <p:spPr>
+          <a:xfrm>
+            <a:off x="4910328" y="3145536"/>
+            <a:ext cx="475488" cy="475488"/>
+          </a:xfrm>
+          <a:prstGeom prst="ellipse">
+            <a:avLst/>
+          </a:prstGeom>
+          <a:solidFill>
+            <a:srgbClr val="1A2C42"/>
+          </a:solidFill>
+          <a:ln w="9525">
+            <a:solidFill>
+              <a:srgbClr val="24364D"/>
+            </a:solidFill>
+            <a:prstDash val="solid"/>
+          </a:ln>
+        </p:spPr>
+        <p:txBody>
+          <a:bodyPr/>
+          <a:lstStyle/>
+          <a:p>
+            <a:endParaRPr lang="sk-SK"/>
+          </a:p>
+        </p:txBody>
+      </p:sp>
+      <p:pic>
+        <p:nvPicPr>
+          <p:cNvPr id="23" name="Image 3" descr="preencoded.png"/>
+          <p:cNvPicPr>
+            <a:picLocks noChangeAspect="1"/>
+          </p:cNvPicPr>
+          <p:nvPr/>
+        </p:nvPicPr>
+        <p:blipFill>
+          <a:blip r:embed="rId6"/>
+          <a:stretch>
+            <a:fillRect/>
+          </a:stretch>
+        </p:blipFill>
+        <p:spPr>
+          <a:xfrm>
+            <a:off x="5038710" y="3273918"/>
+            <a:ext cx="218724" cy="218724"/>
+          </a:xfrm>
+          <a:prstGeom prst="rect">
+            <a:avLst/>
+          </a:prstGeom>
+        </p:spPr>
+      </p:pic>
+      <p:sp>
+        <p:nvSpPr>
+          <p:cNvPr id="24" name="Text 18"/>
+          <p:cNvSpPr/>
+          <p:nvPr/>
+        </p:nvSpPr>
+        <p:spPr>
+          <a:xfrm>
+            <a:off x="5550408" y="3118104"/>
+            <a:ext cx="2880360" cy="310896"/>
+          </a:xfrm>
+          <a:prstGeom prst="rect">
+            <a:avLst/>
+          </a:prstGeom>
+          <a:noFill/>
+          <a:ln/>
+        </p:spPr>
+        <p:txBody>
+          <a:bodyPr wrap="square" lIns="0" tIns="0" rIns="0" bIns="0" rtlCol="0" anchor="ctr"/>
+          <a:lstStyle/>
+          <a:p>
+            <a:pPr marL="0" indent="0">
+              <a:buNone/>
+            </a:pPr>
+            <a:r>
+              <a:rPr lang="en-US" sz="1450" b="1" dirty="0">
+                <a:solidFill>
+                  <a:srgbClr val="F1F6FB"/>
+                </a:solidFill>
+                <a:latin typeface="Arial" pitchFamily="34" charset="0"/>
+                <a:ea typeface="Arial" pitchFamily="34" charset="-122"/>
+                <a:cs typeface="Arial" pitchFamily="34" charset="-120"/>
+              </a:rPr>
+              <a:t>Spolu: ~1 200 – 2 600 € / mes.</a:t>
+            </a:r>
+            <a:endParaRPr lang="en-US" sz="1450" dirty="0"/>
+          </a:p>
+        </p:txBody>
+      </p:sp>
+      <p:sp>
+        <p:nvSpPr>
+          <p:cNvPr id="25" name="Text 19"/>
+          <p:cNvSpPr/>
+          <p:nvPr/>
+        </p:nvSpPr>
+        <p:spPr>
+          <a:xfrm>
+            <a:off x="5550408" y="3456432"/>
+            <a:ext cx="2834640" cy="731520"/>
+          </a:xfrm>
+          <a:prstGeom prst="rect">
+            <a:avLst/>
+          </a:prstGeom>
+          <a:noFill/>
+          <a:ln/>
+        </p:spPr>
+        <p:txBody>
+          <a:bodyPr wrap="square" lIns="0" tIns="0" rIns="0" bIns="0" rtlCol="0" anchor="ctr"/>
+          <a:lstStyle/>
+          <a:p>
+            <a:pPr marL="0" indent="0">
+              <a:lnSpc>
+                <a:spcPct val="108000"/>
+              </a:lnSpc>
+              <a:buNone/>
+            </a:pPr>
+            <a:r>
+              <a:rPr lang="en-US" sz="1050" dirty="0">
+                <a:solidFill>
+                  <a:srgbClr val="8CA6C0"/>
+                </a:solidFill>
+                <a:latin typeface="Arial" pitchFamily="34" charset="0"/>
+                <a:ea typeface="Arial" pitchFamily="34" charset="-122"/>
+                <a:cs typeface="Arial" pitchFamily="34" charset="-120"/>
+              </a:rPr>
+              <a:t>~14 – 31-tis. € / rok pri národnej škále — stále rádovo pod enterprise vývojom.</a:t>
+            </a:r>
+            <a:endParaRPr lang="en-US" sz="1050" dirty="0"/>
+          </a:p>
+        </p:txBody>
+      </p:sp>
+      <p:sp>
+        <p:nvSpPr>
+          <p:cNvPr id="26" name="Shape 20"/>
+          <p:cNvSpPr/>
+          <p:nvPr/>
+        </p:nvSpPr>
+        <p:spPr>
+          <a:xfrm>
+            <a:off x="548640" y="4370832"/>
+            <a:ext cx="8046720" cy="347472"/>
+          </a:xfrm>
+          <a:prstGeom prst="roundRect">
+            <a:avLst>
+              <a:gd name="adj" fmla="val 50000"/>
+            </a:avLst>
+          </a:prstGeom>
+          <a:solidFill>
+            <a:srgbClr val="0D1B2E"/>
+          </a:solidFill>
+          <a:ln w="12700">
+            <a:solidFill>
+              <a:srgbClr val="00D97E"/>
+            </a:solidFill>
+            <a:prstDash val="solid"/>
+          </a:ln>
+        </p:spPr>
+        <p:txBody>
+          <a:bodyPr/>
+          <a:lstStyle/>
+          <a:p>
+            <a:endParaRPr lang="sk-SK"/>
+          </a:p>
+        </p:txBody>
+      </p:sp>
+      <p:sp>
+        <p:nvSpPr>
+          <p:cNvPr id="27" name="Text 21"/>
+          <p:cNvSpPr/>
+          <p:nvPr/>
+        </p:nvSpPr>
+        <p:spPr>
+          <a:xfrm>
+            <a:off x="822960" y="4370832"/>
+            <a:ext cx="7498080" cy="347472"/>
+          </a:xfrm>
+          <a:prstGeom prst="rect">
+            <a:avLst/>
+          </a:prstGeom>
+          <a:noFill/>
+          <a:ln/>
+        </p:spPr>
+        <p:txBody>
+          <a:bodyPr wrap="square" lIns="0" tIns="0" rIns="0" bIns="0" rtlCol="0" anchor="ctr"/>
+          <a:lstStyle/>
+          <a:p>
+            <a:pPr marL="0" indent="0">
+              <a:buNone/>
+            </a:pPr>
+            <a:r>
+              <a:rPr lang="en-US" sz="1100" b="1" dirty="0">
+                <a:solidFill>
+                  <a:srgbClr val="00D97E"/>
+                </a:solidFill>
+                <a:latin typeface="Arial" pitchFamily="34" charset="0"/>
+                <a:ea typeface="Arial" pitchFamily="34" charset="-122"/>
+                <a:cs typeface="Arial" pitchFamily="34" charset="-120"/>
+              </a:rPr>
+              <a:t>Náklady rastú pomalšie než používatelia. </a:t>
+            </a:r>
+            <a:r>
+              <a:rPr lang="en-US" sz="1100" dirty="0">
+                <a:solidFill>
+                  <a:srgbClr val="8CA6C0"/>
+                </a:solidFill>
+                <a:latin typeface="Arial" pitchFamily="34" charset="0"/>
+                <a:ea typeface="Arial" pitchFamily="34" charset="-122"/>
+                <a:cs typeface="Arial" pitchFamily="34" charset="-120"/>
+              </a:rPr>
+              <a:t>PWA + serverless architektúra škáluje takmer lineárne v cene, nie exponenciálne.</a:t>
+            </a:r>
+            <a:endParaRPr lang="en-US" sz="1100" dirty="0"/>
+          </a:p>
+        </p:txBody>
+      </p:sp>
+      <p:pic>
+        <p:nvPicPr>
+          <p:cNvPr id="28" name="Image 4" descr="preencoded.png"/>
+          <p:cNvPicPr>
+            <a:picLocks noChangeAspect="1"/>
+          </p:cNvPicPr>
+          <p:nvPr/>
+        </p:nvPicPr>
+        <p:blipFill>
+          <a:blip r:embed="rId7"/>
+          <a:stretch>
+            <a:fillRect/>
+          </a:stretch>
+        </p:blipFill>
+        <p:spPr>
+          <a:xfrm>
+            <a:off x="548640" y="4828032"/>
+            <a:ext cx="155448" cy="155448"/>
+          </a:xfrm>
+          <a:prstGeom prst="rect">
+            <a:avLst/>
+          </a:prstGeom>
+        </p:spPr>
+      </p:pic>
+      <p:sp>
+        <p:nvSpPr>
+          <p:cNvPr id="29" name="Text 22"/>
+          <p:cNvSpPr/>
+          <p:nvPr/>
+        </p:nvSpPr>
+        <p:spPr>
+          <a:xfrm>
+            <a:off x="777240" y="4809744"/>
+            <a:ext cx="3200400" cy="201168"/>
+          </a:xfrm>
+          <a:prstGeom prst="rect">
+            <a:avLst/>
+          </a:prstGeom>
+          <a:noFill/>
+          <a:ln/>
+        </p:spPr>
+        <p:txBody>
+          <a:bodyPr wrap="square" lIns="0" tIns="0" rIns="0" bIns="0" rtlCol="0" anchor="ctr"/>
+          <a:lstStyle/>
+          <a:p>
+            <a:pPr marL="0" indent="0">
+              <a:buNone/>
+            </a:pPr>
+            <a:r>
+              <a:rPr lang="en-US" sz="850" dirty="0">
+                <a:solidFill>
+                  <a:srgbClr val="8CA6C0"/>
+                </a:solidFill>
+                <a:latin typeface="Arial" pitchFamily="34" charset="0"/>
+                <a:ea typeface="Arial" pitchFamily="34" charset="-122"/>
+                <a:cs typeface="Arial" pitchFamily="34" charset="-120"/>
+              </a:rPr>
+              <a:t>fynd.fans — Beyond the Score</a:t>
+            </a:r>
+            <a:endParaRPr lang="en-US" sz="850" dirty="0"/>
+          </a:p>
+        </p:txBody>
+      </p:sp>
+      <p:sp>
+        <p:nvSpPr>
+          <p:cNvPr id="30" name="Text 23"/>
+          <p:cNvSpPr/>
+          <p:nvPr/>
+        </p:nvSpPr>
+        <p:spPr>
+          <a:xfrm>
+            <a:off x="7680960" y="4809744"/>
+            <a:ext cx="914400" cy="201168"/>
+          </a:xfrm>
+          <a:prstGeom prst="rect">
+            <a:avLst/>
+          </a:prstGeom>
+          <a:noFill/>
+          <a:ln/>
+        </p:spPr>
+        <p:txBody>
+          <a:bodyPr wrap="square" lIns="0" tIns="0" rIns="0" bIns="0" rtlCol="0" anchor="ctr"/>
+          <a:lstStyle/>
+          <a:p>
+            <a:pPr marL="0" indent="0" algn="r">
+              <a:buNone/>
+            </a:pPr>
+            <a:r>
+              <a:rPr lang="en-US" sz="850" dirty="0">
+                <a:solidFill>
+                  <a:srgbClr val="8CA6C0"/>
+                </a:solidFill>
+                <a:latin typeface="Arial" pitchFamily="34" charset="0"/>
+                <a:ea typeface="Arial" pitchFamily="34" charset="-122"/>
+                <a:cs typeface="Arial" pitchFamily="34" charset="-120"/>
+              </a:rPr>
+              <a:t>15 / 18</a:t>
+            </a:r>
+            <a:endParaRPr lang="en-US" sz="850" dirty="0"/>
+          </a:p>
+        </p:txBody>
+      </p:sp>
+    </p:spTree>
+  </p:cSld>
+  <p:clrMapOvr>
+    <a:masterClrMapping/>
+  </p:clrMapOvr>
+  <p:transition spd="slow">
+    <p:push dir="u"/>
+  </p:transition>
+</p:sld>
+</file>
+
+<file path=ppt/slides/slide16.xml><?xml version="1.0" encoding="utf-8"?>
 <p:sld xmlns:a="http://schemas.openxmlformats.org/drawingml/2006/main" xmlns:r="http://schemas.openxmlformats.org/officeDocument/2006/relationships" xmlns:p="http://schemas.openxmlformats.org/presentationml/2006/main">
   <p:cSld name="Slide 9">
     <p:bg>
@@ -6287,7 +10603,7 @@
                 <a:ea typeface="Arial" pitchFamily="34" charset="-122"/>
                 <a:cs typeface="Arial" pitchFamily="34" charset="-120"/>
               </a:rPr>
-              <a:t>12 / 14</a:t>
+              <a:t>16 / 18</a:t>
             </a:r>
             <a:endParaRPr lang="en-US" sz="850" dirty="0"/>
           </a:p>
@@ -6304,7 +10620,7 @@
 </p:sld>
 </file>
 
-<file path=ppt/slides/slide13.xml><?xml version="1.0" encoding="utf-8"?>
+<file path=ppt/slides/slide17.xml><?xml version="1.0" encoding="utf-8"?>
 <p:sld xmlns:a="http://schemas.openxmlformats.org/drawingml/2006/main" xmlns:r="http://schemas.openxmlformats.org/officeDocument/2006/relationships" xmlns:p="http://schemas.openxmlformats.org/presentationml/2006/main">
   <p:cSld name="Slide 10">
     <p:bg>
@@ -7513,7 +11829,7 @@
                 <a:ea typeface="Arial" pitchFamily="34" charset="-122"/>
                 <a:cs typeface="Arial" pitchFamily="34" charset="-120"/>
               </a:rPr>
-              <a:t>13 / 14</a:t>
+              <a:t>17 / 18</a:t>
             </a:r>
             <a:endParaRPr lang="en-US" sz="850" dirty="0"/>
           </a:p>
@@ -7530,7 +11846,7 @@
 </p:sld>
 </file>
 
-<file path=ppt/slides/slide14.xml><?xml version="1.0" encoding="utf-8"?>
+<file path=ppt/slides/slide18.xml><?xml version="1.0" encoding="utf-8"?>
 <p:sld xmlns:a="http://schemas.openxmlformats.org/drawingml/2006/main" xmlns:r="http://schemas.openxmlformats.org/officeDocument/2006/relationships" xmlns:p="http://schemas.openxmlformats.org/presentationml/2006/main">
   <p:cSld name="Slide 11">
     <p:bg>
@@ -8545,7 +12861,7 @@
                 <a:ea typeface="Arial" pitchFamily="34" charset="-122"/>
                 <a:cs typeface="Arial" pitchFamily="34" charset="-120"/>
               </a:rPr>
-              <a:t>14 / 14</a:t>
+              <a:t>18 / 18</a:t>
             </a:r>
             <a:endParaRPr lang="en-US" sz="850" dirty="0"/>
           </a:p>
@@ -9516,7 +13832,7 @@
                 <a:ea typeface="Arial" pitchFamily="34" charset="-122"/>
                 <a:cs typeface="Arial" pitchFamily="34" charset="-120"/>
               </a:rPr>
-              <a:t>02 / 14</a:t>
+              <a:t>02 / 18</a:t>
             </a:r>
             <a:endParaRPr lang="en-US" sz="850" dirty="0"/>
           </a:p>
@@ -10269,7 +14585,7 @@
                 <a:ea typeface="Arial" pitchFamily="34" charset="-122"/>
                 <a:cs typeface="Arial" pitchFamily="34" charset="-120"/>
               </a:rPr>
-              <a:t>03 / 14</a:t>
+              <a:t>03 / 18</a:t>
             </a:r>
             <a:endParaRPr lang="en-US" sz="850" dirty="0"/>
           </a:p>
@@ -11347,7 +15663,7 @@
                 <a:ea typeface="Arial" pitchFamily="34" charset="-122"/>
                 <a:cs typeface="Arial" pitchFamily="34" charset="-120"/>
               </a:rPr>
-              <a:t>04 / 14</a:t>
+              <a:t>04 / 18</a:t>
             </a:r>
             <a:endParaRPr lang="en-US" sz="850" dirty="0"/>
           </a:p>
@@ -12425,7 +16741,7 @@
                 <a:ea typeface="Arial" pitchFamily="34" charset="-122"/>
                 <a:cs typeface="Arial" pitchFamily="34" charset="-120"/>
               </a:rPr>
-              <a:t>05 / 14</a:t>
+              <a:t>05 / 18</a:t>
             </a:r>
             <a:endParaRPr lang="en-US" sz="850" dirty="0"/>
           </a:p>
@@ -13503,7 +17819,7 @@
                 <a:ea typeface="Arial" pitchFamily="34" charset="-122"/>
                 <a:cs typeface="Arial" pitchFamily="34" charset="-120"/>
               </a:rPr>
-              <a:t>06 / 14</a:t>
+              <a:t>06 / 18</a:t>
             </a:r>
             <a:endParaRPr lang="en-US" sz="850" dirty="0"/>
           </a:p>
@@ -14581,7 +18897,7 @@
                 <a:ea typeface="Arial" pitchFamily="34" charset="-122"/>
                 <a:cs typeface="Arial" pitchFamily="34" charset="-120"/>
               </a:rPr>
-              <a:t>07 / 14</a:t>
+              <a:t>07 / 18</a:t>
             </a:r>
             <a:endParaRPr lang="en-US" sz="850" dirty="0"/>
           </a:p>
@@ -16422,7 +20738,7 @@
                 <a:ea typeface="Arial" pitchFamily="34" charset="-122"/>
                 <a:cs typeface="Arial" pitchFamily="34" charset="-120"/>
               </a:rPr>
-              <a:t>08 / 14</a:t>
+              <a:t>08 / 18</a:t>
             </a:r>
             <a:endParaRPr lang="en-US" sz="850" dirty="0"/>
           </a:p>
@@ -17470,7 +21786,7 @@
                 <a:ea typeface="Arial" pitchFamily="34" charset="-122"/>
                 <a:cs typeface="Arial" pitchFamily="34" charset="-120"/>
               </a:rPr>
-              <a:t>09 / 14</a:t>
+              <a:t>09 / 18</a:t>
             </a:r>
             <a:endParaRPr lang="en-US" sz="850" dirty="0"/>
           </a:p>

</xml_diff>